<commit_message>
Regenerate poster: vanilla pptx, n=144 numbers, 55x44 landscape
The previous version used XML post-processing to force a 60x48 slide
size, which appears to have produced a file PowerPoint couldn't open.
Dropping that step: the new file is a plain python-pptx document at
55x44 landscape (same 5:4 aspect as the briefed 48x60 print size).
Print at 48x60 via Design > Slide Size > Custom in PowerPoint (or
let the print shop scale proportionally).

Also update poster content to reflect the n=144 validation registry:
14 / 15 fraud recall at p85 (was 6 / 6 with n=14), 88% specificity,
LOO accuracy 0.87. Reworks the SO WHAT banner and figure captions
accordingly.

Co-Authored-By: Claude Opus 4.7 <noreply@anthropic.com>
</commit_message>
<xml_diff>
--- a/poster templaates/AC297r_Poster_Template.pptx
+++ b/poster templaates/AC297r_Poster_Template.pptx
@@ -1,108 +1,108 @@
 
 <file path=ppt/presentation.xml><?xml version="1.0" encoding="utf-8"?>
-<p:presentation xmlns="http://schemas.openxmlformats.org/drawingml/2006/main" xmlns:ns1="http://schemas.openxmlformats.org/officeDocument/2006/relationships" xmlns:p="http://schemas.openxmlformats.org/presentationml/2006/main" saveSubsetFonts="1" autoCompressPictures="0">
+<p:presentation xmlns:a="http://schemas.openxmlformats.org/drawingml/2006/main" xmlns:r="http://schemas.openxmlformats.org/officeDocument/2006/relationships" xmlns:p="http://schemas.openxmlformats.org/presentationml/2006/main" saveSubsetFonts="1" autoCompressPictures="0">
   <p:sldMasterIdLst>
-    <p:sldMasterId id="2147483648" ns1:id="rId1"/>
+    <p:sldMasterId id="2147483648" r:id="rId1"/>
   </p:sldMasterIdLst>
   <p:sldIdLst>
-    <p:sldId id="256" ns1:id="rId7"/>
+    <p:sldId id="256" r:id="rId7"/>
   </p:sldIdLst>
-  <p:sldSz cx="54864000" cy="43891200" type="screen4x3"/>
+  <p:sldSz cx="50292000" cy="40233600" type="screen4x3"/>
   <p:notesSz cx="6858000" cy="9144000"/>
   <p:defaultTextStyle>
-    <defPPr>
-      <defRPr lang="en-US"/>
-    </defPPr>
-    <lvl1pPr marL="0" algn="l" defTabSz="457200" rtl="0" eaLnBrk="1" latinLnBrk="0" hangingPunct="1">
-      <defRPr sz="1800" kern="1200">
-        <solidFill>
-          <schemeClr val="tx1"/>
-        </solidFill>
-        <latin typeface="+mn-lt"/>
-        <ea typeface="+mn-ea"/>
-        <cs typeface="+mn-cs"/>
-      </defRPr>
-    </lvl1pPr>
-    <lvl2pPr marL="457200" algn="l" defTabSz="457200" rtl="0" eaLnBrk="1" latinLnBrk="0" hangingPunct="1">
-      <defRPr sz="1800" kern="1200">
-        <solidFill>
-          <schemeClr val="tx1"/>
-        </solidFill>
-        <latin typeface="+mn-lt"/>
-        <ea typeface="+mn-ea"/>
-        <cs typeface="+mn-cs"/>
-      </defRPr>
-    </lvl2pPr>
-    <lvl3pPr marL="914400" algn="l" defTabSz="457200" rtl="0" eaLnBrk="1" latinLnBrk="0" hangingPunct="1">
-      <defRPr sz="1800" kern="1200">
-        <solidFill>
-          <schemeClr val="tx1"/>
-        </solidFill>
-        <latin typeface="+mn-lt"/>
-        <ea typeface="+mn-ea"/>
-        <cs typeface="+mn-cs"/>
-      </defRPr>
-    </lvl3pPr>
-    <lvl4pPr marL="1371600" algn="l" defTabSz="457200" rtl="0" eaLnBrk="1" latinLnBrk="0" hangingPunct="1">
-      <defRPr sz="1800" kern="1200">
-        <solidFill>
-          <schemeClr val="tx1"/>
-        </solidFill>
-        <latin typeface="+mn-lt"/>
-        <ea typeface="+mn-ea"/>
-        <cs typeface="+mn-cs"/>
-      </defRPr>
-    </lvl4pPr>
-    <lvl5pPr marL="1828800" algn="l" defTabSz="457200" rtl="0" eaLnBrk="1" latinLnBrk="0" hangingPunct="1">
-      <defRPr sz="1800" kern="1200">
-        <solidFill>
-          <schemeClr val="tx1"/>
-        </solidFill>
-        <latin typeface="+mn-lt"/>
-        <ea typeface="+mn-ea"/>
-        <cs typeface="+mn-cs"/>
-      </defRPr>
-    </lvl5pPr>
-    <lvl6pPr marL="2286000" algn="l" defTabSz="457200" rtl="0" eaLnBrk="1" latinLnBrk="0" hangingPunct="1">
-      <defRPr sz="1800" kern="1200">
-        <solidFill>
-          <schemeClr val="tx1"/>
-        </solidFill>
-        <latin typeface="+mn-lt"/>
-        <ea typeface="+mn-ea"/>
-        <cs typeface="+mn-cs"/>
-      </defRPr>
-    </lvl6pPr>
-    <lvl7pPr marL="2743200" algn="l" defTabSz="457200" rtl="0" eaLnBrk="1" latinLnBrk="0" hangingPunct="1">
-      <defRPr sz="1800" kern="1200">
-        <solidFill>
-          <schemeClr val="tx1"/>
-        </solidFill>
-        <latin typeface="+mn-lt"/>
-        <ea typeface="+mn-ea"/>
-        <cs typeface="+mn-cs"/>
-      </defRPr>
-    </lvl7pPr>
-    <lvl8pPr marL="3200400" algn="l" defTabSz="457200" rtl="0" eaLnBrk="1" latinLnBrk="0" hangingPunct="1">
-      <defRPr sz="1800" kern="1200">
-        <solidFill>
-          <schemeClr val="tx1"/>
-        </solidFill>
-        <latin typeface="+mn-lt"/>
-        <ea typeface="+mn-ea"/>
-        <cs typeface="+mn-cs"/>
-      </defRPr>
-    </lvl8pPr>
-    <lvl9pPr marL="3657600" algn="l" defTabSz="457200" rtl="0" eaLnBrk="1" latinLnBrk="0" hangingPunct="1">
-      <defRPr sz="1800" kern="1200">
-        <solidFill>
-          <schemeClr val="tx1"/>
-        </solidFill>
-        <latin typeface="+mn-lt"/>
-        <ea typeface="+mn-ea"/>
-        <cs typeface="+mn-cs"/>
-      </defRPr>
-    </lvl9pPr>
+    <a:defPPr>
+      <a:defRPr lang="en-US"/>
+    </a:defPPr>
+    <a:lvl1pPr marL="0" algn="l" defTabSz="457200" rtl="0" eaLnBrk="1" latinLnBrk="0" hangingPunct="1">
+      <a:defRPr sz="1800" kern="1200">
+        <a:solidFill>
+          <a:schemeClr val="tx1"/>
+        </a:solidFill>
+        <a:latin typeface="+mn-lt"/>
+        <a:ea typeface="+mn-ea"/>
+        <a:cs typeface="+mn-cs"/>
+      </a:defRPr>
+    </a:lvl1pPr>
+    <a:lvl2pPr marL="457200" algn="l" defTabSz="457200" rtl="0" eaLnBrk="1" latinLnBrk="0" hangingPunct="1">
+      <a:defRPr sz="1800" kern="1200">
+        <a:solidFill>
+          <a:schemeClr val="tx1"/>
+        </a:solidFill>
+        <a:latin typeface="+mn-lt"/>
+        <a:ea typeface="+mn-ea"/>
+        <a:cs typeface="+mn-cs"/>
+      </a:defRPr>
+    </a:lvl2pPr>
+    <a:lvl3pPr marL="914400" algn="l" defTabSz="457200" rtl="0" eaLnBrk="1" latinLnBrk="0" hangingPunct="1">
+      <a:defRPr sz="1800" kern="1200">
+        <a:solidFill>
+          <a:schemeClr val="tx1"/>
+        </a:solidFill>
+        <a:latin typeface="+mn-lt"/>
+        <a:ea typeface="+mn-ea"/>
+        <a:cs typeface="+mn-cs"/>
+      </a:defRPr>
+    </a:lvl3pPr>
+    <a:lvl4pPr marL="1371600" algn="l" defTabSz="457200" rtl="0" eaLnBrk="1" latinLnBrk="0" hangingPunct="1">
+      <a:defRPr sz="1800" kern="1200">
+        <a:solidFill>
+          <a:schemeClr val="tx1"/>
+        </a:solidFill>
+        <a:latin typeface="+mn-lt"/>
+        <a:ea typeface="+mn-ea"/>
+        <a:cs typeface="+mn-cs"/>
+      </a:defRPr>
+    </a:lvl4pPr>
+    <a:lvl5pPr marL="1828800" algn="l" defTabSz="457200" rtl="0" eaLnBrk="1" latinLnBrk="0" hangingPunct="1">
+      <a:defRPr sz="1800" kern="1200">
+        <a:solidFill>
+          <a:schemeClr val="tx1"/>
+        </a:solidFill>
+        <a:latin typeface="+mn-lt"/>
+        <a:ea typeface="+mn-ea"/>
+        <a:cs typeface="+mn-cs"/>
+      </a:defRPr>
+    </a:lvl5pPr>
+    <a:lvl6pPr marL="2286000" algn="l" defTabSz="457200" rtl="0" eaLnBrk="1" latinLnBrk="0" hangingPunct="1">
+      <a:defRPr sz="1800" kern="1200">
+        <a:solidFill>
+          <a:schemeClr val="tx1"/>
+        </a:solidFill>
+        <a:latin typeface="+mn-lt"/>
+        <a:ea typeface="+mn-ea"/>
+        <a:cs typeface="+mn-cs"/>
+      </a:defRPr>
+    </a:lvl6pPr>
+    <a:lvl7pPr marL="2743200" algn="l" defTabSz="457200" rtl="0" eaLnBrk="1" latinLnBrk="0" hangingPunct="1">
+      <a:defRPr sz="1800" kern="1200">
+        <a:solidFill>
+          <a:schemeClr val="tx1"/>
+        </a:solidFill>
+        <a:latin typeface="+mn-lt"/>
+        <a:ea typeface="+mn-ea"/>
+        <a:cs typeface="+mn-cs"/>
+      </a:defRPr>
+    </a:lvl7pPr>
+    <a:lvl8pPr marL="3200400" algn="l" defTabSz="457200" rtl="0" eaLnBrk="1" latinLnBrk="0" hangingPunct="1">
+      <a:defRPr sz="1800" kern="1200">
+        <a:solidFill>
+          <a:schemeClr val="tx1"/>
+        </a:solidFill>
+        <a:latin typeface="+mn-lt"/>
+        <a:ea typeface="+mn-ea"/>
+        <a:cs typeface="+mn-cs"/>
+      </a:defRPr>
+    </a:lvl8pPr>
+    <a:lvl9pPr marL="3657600" algn="l" defTabSz="457200" rtl="0" eaLnBrk="1" latinLnBrk="0" hangingPunct="1">
+      <a:defRPr sz="1800" kern="1200">
+        <a:solidFill>
+          <a:schemeClr val="tx1"/>
+        </a:solidFill>
+        <a:latin typeface="+mn-lt"/>
+        <a:ea typeface="+mn-ea"/>
+        <a:cs typeface="+mn-cs"/>
+      </a:defRPr>
+    </a:lvl9pPr>
   </p:defaultTextStyle>
 </p:presentation>
 </file>
@@ -3079,7 +3079,7 @@
 </file>
 
 <file path=ppt/slides/slide1.xml><?xml version="1.0" encoding="utf-8"?>
-<p:sld xmlns="http://schemas.openxmlformats.org/drawingml/2006/main" xmlns:ns2="http://schemas.openxmlformats.org/officeDocument/2006/relationships" xmlns:p="http://schemas.openxmlformats.org/presentationml/2006/main">
+<p:sld xmlns:a="http://schemas.openxmlformats.org/drawingml/2006/main" xmlns:p="http://schemas.openxmlformats.org/presentationml/2006/main" xmlns:r="http://schemas.openxmlformats.org/officeDocument/2006/relationships">
   <p:cSld>
     <p:spTree>
       <p:nvGrpSpPr>
@@ -3095,1496 +3095,1475 @@
           <p:nvPr/>
         </p:nvSpPr>
         <p:spPr>
-          <xfrm>
-            <off x="0" y="0"/>
-            <ext cx="54863999" cy="43891200"/>
-          </xfrm>
-          <prstGeom prst="rect">
-            <avLst/>
-          </prstGeom>
-          <solidFill>
-            <srgbClr val="FFFFFF"/>
-          </solidFill>
-          <ln>
-            <noFill/>
-          </ln>
+          <a:xfrm>
+            <a:off x="0" y="0"/>
+            <a:ext cx="50292000" cy="40233600"/>
+          </a:xfrm>
+          <a:prstGeom prst="rect">
+            <a:avLst/>
+          </a:prstGeom>
+          <a:solidFill>
+            <a:srgbClr val="FFFFFF"/>
+          </a:solidFill>
+          <a:ln>
+            <a:noFill/>
+          </a:ln>
         </p:spPr>
         <p:style>
-          <lnRef idx="1">
-            <schemeClr val="accent1"/>
-          </lnRef>
-          <fillRef idx="3">
-            <schemeClr val="accent1"/>
-          </fillRef>
-          <effectRef idx="2">
-            <schemeClr val="accent1"/>
-          </effectRef>
-          <fontRef idx="minor">
-            <schemeClr val="lt1"/>
-          </fontRef>
+          <a:lnRef idx="1">
+            <a:schemeClr val="accent1"/>
+          </a:lnRef>
+          <a:fillRef idx="3">
+            <a:schemeClr val="accent1"/>
+          </a:fillRef>
+          <a:effectRef idx="2">
+            <a:schemeClr val="accent1"/>
+          </a:effectRef>
+          <a:fontRef idx="minor">
+            <a:schemeClr val="lt1"/>
+          </a:fontRef>
         </p:style>
         <p:txBody>
-          <bodyPr rtlCol="0" anchor="ctr"/>
-          <lstStyle/>
-          <p>
-            <pPr algn="ctr"/>
-          </p>
-        </p:txBody>
-      </p:sp>
-      <p:sp>
-        <p:nvSpPr>
-          <p:cNvPr id="3" name="Rectangle 2"/>
-          <p:cNvSpPr/>
-          <p:nvPr/>
-        </p:nvSpPr>
-        <p:spPr>
-          <xfrm>
-            <off x="897774" y="598516"/>
-            <ext cx="3192087" cy="3591098"/>
-          </xfrm>
-          <prstGeom prst="rect">
-            <avLst/>
-          </prstGeom>
-          <solidFill>
-            <srgbClr val="F5F5F5"/>
-          </solidFill>
-          <ln w="9525">
-            <solidFill>
-              <srgbClr val="D8D8D8"/>
-            </solidFill>
-          </ln>
-          <effectLst/>
-        </p:spPr>
-        <p:style>
-          <lnRef idx="1">
-            <schemeClr val="accent1"/>
-          </lnRef>
-          <fillRef idx="3">
-            <schemeClr val="accent1"/>
-          </fillRef>
-          <effectRef idx="2">
-            <schemeClr val="accent1"/>
-          </effectRef>
-          <fontRef idx="minor">
-            <schemeClr val="lt1"/>
-          </fontRef>
-        </p:style>
-        <p:txBody>
-          <bodyPr rtlCol="0" anchor="ctr"/>
-          <lstStyle/>
-          <p>
-            <pPr algn="ctr"/>
-          </p>
-        </p:txBody>
-      </p:sp>
-      <p:sp>
-        <p:nvSpPr>
-          <p:cNvPr id="4" name="TextBox 3"/>
-          <p:cNvSpPr txBox="1"/>
-          <p:nvPr/>
-        </p:nvSpPr>
-        <p:spPr>
-          <xfrm>
-            <off x="897774" y="2094807"/>
-            <ext cx="3192087" cy="698269"/>
-          </xfrm>
-          <prstGeom prst="rect">
-            <avLst/>
-          </prstGeom>
-          <noFill/>
-        </p:spPr>
-        <p:txBody>
-          <bodyPr wrap="square" anchor="t">
-            <spAutoFit/>
-          </bodyPr>
-          <lstStyle/>
-          <p>
-            <pPr algn="ctr">
-              <lnSpc>
-                <spcPct val="115000"/>
-              </lnSpc>
-            </pPr>
-            <r>
-              <rPr sz="2181" b="0" i="1">
-                <solidFill>
-                  <srgbClr val="999999"/>
-                </solidFill>
-                <latin typeface="Calibri"/>
-              </rPr>
-              <t>[ shield ]</t>
-            </r>
-          </p>
-        </p:txBody>
-      </p:sp>
-      <p:sp>
-        <p:nvSpPr>
-          <p:cNvPr id="5" name="Rectangle 4"/>
-          <p:cNvSpPr/>
-          <p:nvPr/>
-        </p:nvSpPr>
-        <p:spPr>
-          <xfrm>
-            <off x="50774138" y="598516"/>
-            <ext cx="3192087" cy="3591098"/>
-          </xfrm>
-          <prstGeom prst="rect">
-            <avLst/>
-          </prstGeom>
-          <solidFill>
-            <srgbClr val="F5F5F5"/>
-          </solidFill>
-          <ln w="9525">
-            <solidFill>
-              <srgbClr val="D8D8D8"/>
-            </solidFill>
-          </ln>
-          <effectLst/>
-        </p:spPr>
-        <p:style>
-          <lnRef idx="1">
-            <schemeClr val="accent1"/>
-          </lnRef>
-          <fillRef idx="3">
-            <schemeClr val="accent1"/>
-          </fillRef>
-          <effectRef idx="2">
-            <schemeClr val="accent1"/>
-          </effectRef>
-          <fontRef idx="minor">
-            <schemeClr val="lt1"/>
-          </fontRef>
-        </p:style>
-        <p:txBody>
-          <bodyPr rtlCol="0" anchor="ctr"/>
-          <lstStyle/>
-          <p>
-            <pPr algn="ctr"/>
-          </p>
-        </p:txBody>
-      </p:sp>
-      <p:sp>
-        <p:nvSpPr>
-          <p:cNvPr id="6" name="TextBox 5"/>
-          <p:cNvSpPr txBox="1"/>
-          <p:nvPr/>
-        </p:nvSpPr>
-        <p:spPr>
-          <xfrm>
-            <off x="50774138" y="2094807"/>
-            <ext cx="3192087" cy="698269"/>
-          </xfrm>
-          <prstGeom prst="rect">
-            <avLst/>
-          </prstGeom>
-          <noFill/>
-        </p:spPr>
-        <p:txBody>
-          <bodyPr wrap="square" anchor="t">
-            <spAutoFit/>
-          </bodyPr>
-          <lstStyle/>
-          <p>
-            <pPr algn="ctr">
-              <lnSpc>
-                <spcPct val="115000"/>
-              </lnSpc>
-            </pPr>
-            <r>
-              <rPr sz="2181" b="0" i="1">
-                <solidFill>
-                  <srgbClr val="999999"/>
-                </solidFill>
-                <latin typeface="Calibri"/>
-              </rPr>
-              <t>[ shield ]</t>
-            </r>
-          </p>
-        </p:txBody>
-      </p:sp>
-      <p:sp>
-        <p:nvSpPr>
-          <p:cNvPr id="7" name="TextBox 6"/>
-          <p:cNvSpPr txBox="1"/>
-          <p:nvPr/>
-        </p:nvSpPr>
-        <p:spPr>
-          <xfrm>
-            <off x="4488872" y="598516"/>
-            <ext cx="45886254" cy="2593570"/>
-          </xfrm>
-          <prstGeom prst="rect">
-            <avLst/>
-          </prstGeom>
-          <noFill/>
-        </p:spPr>
-        <p:txBody>
-          <bodyPr wrap="square" anchor="t">
-            <spAutoFit/>
-          </bodyPr>
-          <lstStyle/>
-          <p>
-            <pPr algn="ctr">
-              <lnSpc>
-                <spcPct val="105000"/>
-              </lnSpc>
-            </pPr>
-            <r>
-              <rPr sz="6763" b="1" i="0">
-                <solidFill>
-                  <srgbClr val="A51C30"/>
-                </solidFill>
-                <latin typeface="Georgia"/>
-              </rPr>
-              <t>Detecting crypto fraud without labels:</t>
-            </r>
-          </p>
-          <p>
-            <pPr algn="ctr">
-              <lnSpc>
-                <spcPct val="105000"/>
-              </lnSpc>
-            </pPr>
-            <r>
-              <rPr sz="6763" b="1" i="0">
-                <solidFill>
-                  <srgbClr val="A51C30"/>
-                </solidFill>
-                <latin typeface="Georgia"/>
-              </rPr>
-              <t>6 of 6 known rug pulls recovered from 4,334 Ethereum tokens.</t>
-            </r>
-          </p>
-        </p:txBody>
-      </p:sp>
-      <p:sp>
-        <p:nvSpPr>
-          <p:cNvPr id="8" name="TextBox 7"/>
-          <p:cNvSpPr txBox="1"/>
-          <p:nvPr/>
-        </p:nvSpPr>
-        <p:spPr>
-          <xfrm>
-            <off x="4488872" y="3291839"/>
-            <ext cx="45886254" cy="698269"/>
-          </xfrm>
-          <prstGeom prst="rect">
-            <avLst/>
-          </prstGeom>
-          <noFill/>
-        </p:spPr>
-        <p:txBody>
-          <bodyPr wrap="square" anchor="t">
-            <spAutoFit/>
-          </bodyPr>
-          <lstStyle/>
-          <p>
-            <pPr algn="ctr">
-              <lnSpc>
-                <spcPct val="115000"/>
-              </lnSpc>
-            </pPr>
-            <r>
-              <rPr sz="3054" b="0" i="0">
-                <solidFill>
-                  <srgbClr val="2A2A2A"/>
-                </solidFill>
-                <latin typeface="Georgia"/>
-              </rPr>
-              <t>Gillian Schriever  ·  Jiahui (Cecilia) Cai  ·  Zhilin Chen  ·  Jinghan Huang</t>
-            </r>
-          </p>
-        </p:txBody>
-      </p:sp>
-      <p:sp>
-        <p:nvSpPr>
-          <p:cNvPr id="9" name="TextBox 8"/>
-          <p:cNvSpPr txBox="1"/>
-          <p:nvPr/>
-        </p:nvSpPr>
-        <p:spPr>
-          <xfrm>
-            <off x="4488872" y="3990109"/>
-            <ext cx="45886254" cy="598516"/>
-          </xfrm>
-          <prstGeom prst="rect">
-            <avLst/>
-          </prstGeom>
-          <noFill/>
-        </p:spPr>
-        <p:txBody>
-          <bodyPr wrap="square" anchor="t">
-            <spAutoFit/>
-          </bodyPr>
-          <lstStyle/>
-          <p>
-            <pPr algn="ctr">
-              <lnSpc>
-                <spcPct val="115000"/>
-              </lnSpc>
-            </pPr>
-            <r>
-              <rPr sz="2400" b="0" i="1">
-                <solidFill>
-                  <srgbClr val="2A2A2A"/>
-                </solidFill>
-                <latin typeface="Georgia"/>
-              </rPr>
-              <t>Harvard John A. Paulson School of Engineering and Applied Sciences  —  AC297r Capstone, Spring 2026</t>
-            </r>
-          </p>
-        </p:txBody>
-      </p:sp>
-      <p:sp>
-        <p:nvSpPr>
-          <p:cNvPr id="10" name="Rectangle 9"/>
-          <p:cNvSpPr/>
-          <p:nvPr/>
-        </p:nvSpPr>
-        <p:spPr>
-          <xfrm>
-            <off x="0" y="4788130"/>
-            <ext cx="54863999" cy="39901"/>
-          </xfrm>
-          <prstGeom prst="rect">
-            <avLst/>
-          </prstGeom>
-          <solidFill>
-            <srgbClr val="A51C30"/>
-          </solidFill>
-          <ln>
-            <noFill/>
-          </ln>
-          <effectLst/>
-        </p:spPr>
-        <p:style>
-          <lnRef idx="1">
-            <schemeClr val="accent1"/>
-          </lnRef>
-          <fillRef idx="3">
-            <schemeClr val="accent1"/>
-          </fillRef>
-          <effectRef idx="2">
-            <schemeClr val="accent1"/>
-          </effectRef>
-          <fontRef idx="minor">
-            <schemeClr val="lt1"/>
-          </fontRef>
-        </p:style>
-        <p:txBody>
-          <bodyPr rtlCol="0" anchor="ctr"/>
-          <lstStyle/>
-          <p>
-            <pPr algn="ctr"/>
-          </p>
-        </p:txBody>
-      </p:sp>
-      <p:sp>
-        <p:nvSpPr>
-          <p:cNvPr id="11" name="TextBox 10"/>
-          <p:cNvSpPr txBox="1"/>
-          <p:nvPr/>
-        </p:nvSpPr>
-        <p:spPr>
-          <xfrm>
-            <off x="897774" y="5486400"/>
-            <ext cx="17090967" cy="897774"/>
-          </xfrm>
-          <prstGeom prst="rect">
-            <avLst/>
-          </prstGeom>
-          <noFill/>
-        </p:spPr>
-        <p:txBody>
-          <bodyPr wrap="square" anchor="t">
-            <spAutoFit/>
-          </bodyPr>
-          <lstStyle/>
-          <p>
-            <pPr algn="l">
-              <lnSpc>
-                <spcPct val="115000"/>
-              </lnSpc>
-            </pPr>
-            <r>
-              <rPr sz="4581" b="1" i="0">
-                <solidFill>
-                  <srgbClr val="A51C30"/>
-                </solidFill>
-                <latin typeface="Calibri"/>
-              </rPr>
-              <t>THE QUESTION</t>
-            </r>
-          </p>
-        </p:txBody>
-      </p:sp>
-      <p:sp>
-        <p:nvSpPr>
-          <p:cNvPr id="12" name="Rectangle 11"/>
-          <p:cNvSpPr/>
-          <p:nvPr/>
-        </p:nvSpPr>
-        <p:spPr>
-          <xfrm>
-            <off x="897774" y="6483927"/>
-            <ext cx="5981838" cy="39901"/>
-          </xfrm>
-          <prstGeom prst="rect">
-            <avLst/>
-          </prstGeom>
-          <solidFill>
-            <srgbClr val="A51C30"/>
-          </solidFill>
-          <ln>
-            <noFill/>
-          </ln>
-          <effectLst/>
-        </p:spPr>
-        <p:style>
-          <lnRef idx="1">
-            <schemeClr val="accent1"/>
-          </lnRef>
-          <fillRef idx="3">
-            <schemeClr val="accent1"/>
-          </fillRef>
-          <effectRef idx="2">
-            <schemeClr val="accent1"/>
-          </effectRef>
-          <fontRef idx="minor">
-            <schemeClr val="lt1"/>
-          </fontRef>
-        </p:style>
-        <p:txBody>
-          <bodyPr rtlCol="0" anchor="ctr"/>
-          <lstStyle/>
-          <p>
-            <pPr algn="ctr"/>
-          </p>
-        </p:txBody>
-      </p:sp>
-      <p:sp>
-        <p:nvSpPr>
-          <p:cNvPr id="13" name="TextBox 12"/>
-          <p:cNvSpPr txBox="1"/>
-          <p:nvPr/>
-        </p:nvSpPr>
-        <p:spPr>
-          <xfrm>
-            <off x="897774" y="6882938"/>
-            <ext cx="17090967" cy="3391592"/>
-          </xfrm>
-          <prstGeom prst="rect">
-            <avLst/>
-          </prstGeom>
-          <noFill/>
-        </p:spPr>
-        <p:txBody>
-          <bodyPr wrap="square" anchor="t">
-            <spAutoFit/>
-          </bodyPr>
-          <lstStyle/>
-          <p>
-            <pPr algn="l">
-              <lnSpc>
-                <spcPct val="115000"/>
-              </lnSpc>
-            </pPr>
-            <r>
-              <rPr sz="3490" b="1" i="0">
-                <solidFill>
-                  <srgbClr val="2A2A2A"/>
-                </solidFill>
-                <latin typeface="Calibri"/>
-              </rPr>
-              <t>Can we detect crypto fraud without any labeled data?</t>
-            </r>
-          </p>
-        </p:txBody>
-      </p:sp>
-      <p:sp>
-        <p:nvSpPr>
-          <p:cNvPr id="14" name="TextBox 13"/>
-          <p:cNvSpPr txBox="1"/>
-          <p:nvPr/>
-        </p:nvSpPr>
-        <p:spPr>
-          <xfrm>
-            <off x="897774" y="9875520"/>
-            <ext cx="17090967" cy="8977745"/>
-          </xfrm>
-          <prstGeom prst="rect">
-            <avLst/>
-          </prstGeom>
-          <noFill/>
-        </p:spPr>
-        <p:txBody>
-          <bodyPr wrap="square" anchor="t">
-            <spAutoFit/>
-          </bodyPr>
-          <lstStyle/>
-          <p>
-            <pPr algn="l">
-              <lnSpc>
-                <spcPct val="125000"/>
-              </lnSpc>
-            </pPr>
-            <r>
-              <rPr sz="2618" b="0" i="0">
-                <solidFill>
-                  <srgbClr val="2A2A2A"/>
-                </solidFill>
-                <latin typeface="Calibri"/>
-              </rPr>
-              <t>Labels for crypto fraud are rare, slow to publish, and biased</t>
-            </r>
-          </p>
-          <p>
-            <pPr algn="l">
-              <lnSpc>
-                <spcPct val="125000"/>
-              </lnSpc>
-            </pPr>
-            <r>
-              <rPr sz="2618" b="0" i="0">
-                <solidFill>
-                  <srgbClr val="2A2A2A"/>
-                </solidFill>
-                <latin typeface="Calibri"/>
-              </rPr>
-              <t>toward high-profile cases. Supervised classifiers trained on</t>
-            </r>
-          </p>
-          <p>
-            <pPr algn="l">
-              <lnSpc>
-                <spcPct val="125000"/>
-              </lnSpc>
-            </pPr>
-            <r>
-              <rPr sz="2618" b="0" i="0">
-                <solidFill>
-                  <srgbClr val="2A2A2A"/>
-                </solidFill>
-                <latin typeface="Calibri"/>
-              </rPr>
-              <t>them don't generalize — the attacks evolve faster than the</t>
-            </r>
-          </p>
-          <p>
-            <pPr algn="l">
-              <lnSpc>
-                <spcPct val="125000"/>
-              </lnSpc>
-            </pPr>
-            <r>
-              <rPr sz="2618" b="0" i="0">
-                <solidFill>
-                  <srgbClr val="2A2A2A"/>
-                </solidFill>
-                <latin typeface="Calibri"/>
-              </rPr>
-              <t>labels.</t>
-            </r>
-          </p>
-          <p>
-            <pPr algn="l">
-              <lnSpc>
-                <spcPct val="125000"/>
-              </lnSpc>
-            </pPr>
-            <r>
-              <rPr sz="2618" b="0" i="0">
-                <solidFill>
-                  <srgbClr val="2A2A2A"/>
-                </solidFill>
-                <latin typeface="Calibri"/>
-              </rPr>
-              <t/>
-            </r>
-          </p>
-          <p>
-            <pPr algn="l">
-              <lnSpc>
-                <spcPct val="125000"/>
-              </lnSpc>
-            </pPr>
-            <r>
-              <rPr sz="2618" b="0" i="0">
-                <solidFill>
-                  <srgbClr val="2A2A2A"/>
-                </solidFill>
-                <latin typeface="Calibri"/>
-              </rPr>
-              <t>We build a two-layer unsupervised pipeline:</t>
-            </r>
-          </p>
-          <p>
-            <pPr algn="l">
-              <lnSpc>
-                <spcPct val="125000"/>
-              </lnSpc>
-            </pPr>
-            <r>
-              <rPr sz="2618" b="0" i="0">
-                <solidFill>
-                  <srgbClr val="2A2A2A"/>
-                </solidFill>
-                <latin typeface="Calibri"/>
-              </rPr>
-              <t/>
-            </r>
-          </p>
-          <p>
-            <pPr algn="l">
-              <lnSpc>
-                <spcPct val="125000"/>
-              </lnSpc>
-            </pPr>
-            <r>
-              <rPr sz="2618" b="0" i="0">
-                <solidFill>
-                  <srgbClr val="2A2A2A"/>
-                </solidFill>
-                <latin typeface="Calibri"/>
-              </rPr>
-              <t>  ① Flag tokens whose on-chain trading behavior looks</t>
-            </r>
-          </p>
-          <p>
-            <pPr algn="l">
-              <lnSpc>
-                <spcPct val="125000"/>
-              </lnSpc>
-            </pPr>
-            <r>
-              <rPr sz="2618" b="0" i="0">
-                <solidFill>
-                  <srgbClr val="2A2A2A"/>
-                </solidFill>
-                <latin typeface="Calibri"/>
-              </rPr>
-              <t>      statistically unusual.</t>
-            </r>
-          </p>
-          <p>
-            <pPr algn="l">
-              <lnSpc>
-                <spcPct val="125000"/>
-              </lnSpc>
-            </pPr>
-            <r>
-              <rPr sz="2618" b="0" i="0">
-                <solidFill>
-                  <srgbClr val="2A2A2A"/>
-                </solidFill>
-                <latin typeface="Calibri"/>
-              </rPr>
-              <t/>
-            </r>
-          </p>
-          <p>
-            <pPr algn="l">
-              <lnSpc>
-                <spcPct val="125000"/>
-              </lnSpc>
-            </pPr>
-            <r>
-              <rPr sz="2618" b="0" i="0">
-                <solidFill>
-                  <srgbClr val="2A2A2A"/>
-                </solidFill>
-                <latin typeface="Calibri"/>
-              </rPr>
-              <t>  ② Estimate how likely that unusual behavior is to be</t>
-            </r>
-          </p>
-          <p>
-            <pPr algn="l">
-              <lnSpc>
-                <spcPct val="125000"/>
-              </lnSpc>
-            </pPr>
-            <r>
-              <rPr sz="2618" b="0" i="0">
-                <solidFill>
-                  <srgbClr val="2A2A2A"/>
-                </solidFill>
-                <latin typeface="Calibri"/>
-              </rPr>
-              <t>      intentional fraud (vs. a hack, bug, or large legitimate</t>
-            </r>
-          </p>
-          <p>
-            <pPr algn="l">
-              <lnSpc>
-                <spcPct val="125000"/>
-              </lnSpc>
-            </pPr>
-            <r>
-              <rPr sz="2618" b="0" i="0">
-                <solidFill>
-                  <srgbClr val="2A2A2A"/>
-                </solidFill>
-                <latin typeface="Calibri"/>
-              </rPr>
-              <t>      event).</t>
-            </r>
-          </p>
-        </p:txBody>
-      </p:sp>
-      <p:sp>
-        <p:nvSpPr>
-          <p:cNvPr id="15" name="TextBox 14"/>
-          <p:cNvSpPr txBox="1"/>
-          <p:nvPr/>
-        </p:nvSpPr>
-        <p:spPr>
-          <xfrm>
-            <off x="18886516" y="5486400"/>
-            <ext cx="17090967" cy="897774"/>
-          </xfrm>
-          <prstGeom prst="rect">
-            <avLst/>
-          </prstGeom>
-          <noFill/>
-        </p:spPr>
-        <p:txBody>
-          <bodyPr wrap="square" anchor="t">
-            <spAutoFit/>
-          </bodyPr>
-          <lstStyle/>
-          <p>
-            <pPr algn="l">
-              <lnSpc>
-                <spcPct val="115000"/>
-              </lnSpc>
-            </pPr>
-            <r>
-              <rPr sz="4581" b="1" i="0">
-                <solidFill>
-                  <srgbClr val="A51C30"/>
-                </solidFill>
-                <latin typeface="Calibri"/>
-              </rPr>
-              <t>METHODS</t>
-            </r>
-          </p>
-        </p:txBody>
-      </p:sp>
-      <p:sp>
-        <p:nvSpPr>
-          <p:cNvPr id="16" name="Rectangle 15"/>
-          <p:cNvSpPr/>
-          <p:nvPr/>
-        </p:nvSpPr>
-        <p:spPr>
-          <xfrm>
-            <off x="18886516" y="6483927"/>
-            <ext cx="5981838" cy="39901"/>
-          </xfrm>
-          <prstGeom prst="rect">
-            <avLst/>
-          </prstGeom>
-          <solidFill>
-            <srgbClr val="A51C30"/>
-          </solidFill>
-          <ln>
-            <noFill/>
-          </ln>
-          <effectLst/>
-        </p:spPr>
-        <p:style>
-          <lnRef idx="1">
-            <schemeClr val="accent1"/>
-          </lnRef>
-          <fillRef idx="3">
-            <schemeClr val="accent1"/>
-          </fillRef>
-          <effectRef idx="2">
-            <schemeClr val="accent1"/>
-          </effectRef>
-          <fontRef idx="minor">
-            <schemeClr val="lt1"/>
-          </fontRef>
-        </p:style>
-        <p:txBody>
-          <bodyPr rtlCol="0" anchor="ctr"/>
-          <lstStyle/>
-          <p>
-            <pPr algn="ctr"/>
-          </p>
-        </p:txBody>
-      </p:sp>
-      <p:sp>
-        <p:nvSpPr>
-          <p:cNvPr id="17" name="TextBox 16"/>
-          <p:cNvSpPr txBox="1"/>
-          <p:nvPr/>
-        </p:nvSpPr>
-        <p:spPr>
-          <xfrm>
-            <off x="18886516" y="6882938"/>
-            <ext cx="17090967" cy="13466618"/>
-          </xfrm>
-          <prstGeom prst="rect">
-            <avLst/>
-          </prstGeom>
-          <noFill/>
-        </p:spPr>
-        <p:txBody>
-          <bodyPr wrap="square" anchor="t">
-            <spAutoFit/>
-          </bodyPr>
-          <lstStyle/>
-          <p>
-            <pPr algn="l">
-              <lnSpc>
-                <spcPct val="125000"/>
-              </lnSpc>
-            </pPr>
-            <r>
-              <rPr sz="2618" b="0" i="0">
-                <solidFill>
-                  <srgbClr val="2A2A2A"/>
-                </solidFill>
-                <latin typeface="Calibri"/>
-              </rPr>
-              <t>Data. 4,334 mid-cap ERC-20 tokens on Ethereum</t>
-            </r>
-          </p>
-          <p>
-            <pPr algn="l">
-              <lnSpc>
-                <spcPct val="125000"/>
-              </lnSpc>
-            </pPr>
-            <r>
-              <rPr sz="2618" b="0" i="0">
-                <solidFill>
-                  <srgbClr val="2A2A2A"/>
-                </solidFill>
-                <latin typeface="Calibri"/>
-              </rPr>
-              <t>(Dune Analytics, 365-day window, $1M–$1B annual volume).</t>
-            </r>
-          </p>
-          <p>
-            <pPr algn="l">
-              <lnSpc>
-                <spcPct val="125000"/>
-              </lnSpc>
-            </pPr>
-            <r>
-              <rPr sz="2618" b="0" i="0">
-                <solidFill>
-                  <srgbClr val="2A2A2A"/>
-                </solidFill>
-                <latin typeface="Calibri"/>
-              </rPr>
-              <t/>
-            </r>
-          </p>
-          <p>
-            <pPr algn="l">
-              <lnSpc>
-                <spcPct val="125000"/>
-              </lnSpc>
-            </pPr>
-            <r>
-              <rPr sz="2618" b="0" i="0">
-                <solidFill>
-                  <srgbClr val="2A2A2A"/>
-                </solidFill>
-                <latin typeface="Calibri"/>
-              </rPr>
-              <t>Features (6). Volume spike ratio, peak daily volume, days</t>
-            </r>
-          </p>
-          <p>
-            <pPr algn="l">
-              <lnSpc>
-                <spcPct val="125000"/>
-              </lnSpc>
-            </pPr>
-            <r>
-              <rPr sz="2618" b="0" i="0">
-                <solidFill>
-                  <srgbClr val="2A2A2A"/>
-                </solidFill>
-                <latin typeface="Calibri"/>
-              </rPr>
-              <t>traded, max single-trade dominance, and two 24-hour post-</t>
-            </r>
-          </p>
-          <p>
-            <pPr algn="l">
-              <lnSpc>
-                <spcPct val="125000"/>
-              </lnSpc>
-            </pPr>
-            <r>
-              <rPr sz="2618" b="0" i="0">
-                <solidFill>
-                  <srgbClr val="2A2A2A"/>
-                </solidFill>
-                <latin typeface="Calibri"/>
-              </rPr>
-              <t>launch velocity features.</t>
-            </r>
-          </p>
-          <p>
-            <pPr algn="l">
-              <lnSpc>
-                <spcPct val="125000"/>
-              </lnSpc>
-            </pPr>
-            <r>
-              <rPr sz="2618" b="0" i="0">
-                <solidFill>
-                  <srgbClr val="2A2A2A"/>
-                </solidFill>
-                <latin typeface="Calibri"/>
-              </rPr>
-              <t/>
-            </r>
-          </p>
-          <p>
-            <pPr algn="l">
-              <lnSpc>
-                <spcPct val="125000"/>
-              </lnSpc>
-            </pPr>
-            <r>
-              <rPr sz="2618" b="0" i="0">
-                <solidFill>
-                  <srgbClr val="2A2A2A"/>
-                </solidFill>
-                <latin typeface="Calibri"/>
-              </rPr>
-              <t>Layer 1 — three independent detectors:</t>
-            </r>
-          </p>
-          <p>
-            <pPr algn="l">
-              <lnSpc>
-                <spcPct val="125000"/>
-              </lnSpc>
-            </pPr>
-            <r>
-              <rPr sz="2618" b="0" i="0">
-                <solidFill>
-                  <srgbClr val="2A2A2A"/>
-                </solidFill>
-                <latin typeface="Calibri"/>
-              </rPr>
-              <t>    •  Isolation Forest (tree-based outlier detection)</t>
-            </r>
-          </p>
-          <p>
-            <pPr algn="l">
-              <lnSpc>
-                <spcPct val="125000"/>
-              </lnSpc>
-            </pPr>
-            <r>
-              <rPr sz="2618" b="0" i="0">
-                <solidFill>
-                  <srgbClr val="2A2A2A"/>
-                </solidFill>
-                <latin typeface="Calibri"/>
-              </rPr>
-              <t>    •  DBSCAN (density clustering; we keep the noise points)</t>
-            </r>
-          </p>
-          <p>
-            <pPr algn="l">
-              <lnSpc>
-                <spcPct val="125000"/>
-              </lnSpc>
-            </pPr>
-            <r>
-              <rPr sz="2618" b="0" i="0">
-                <solidFill>
-                  <srgbClr val="2A2A2A"/>
-                </solidFill>
-                <latin typeface="Calibri"/>
-              </rPr>
-              <t>    •  PCA + Mahalanobis distance</t>
-            </r>
-          </p>
-          <p>
-            <pPr algn="l">
-              <lnSpc>
-                <spcPct val="125000"/>
-              </lnSpc>
-            </pPr>
-            <r>
-              <rPr sz="2618" b="0" i="0">
-                <solidFill>
-                  <srgbClr val="2A2A2A"/>
-                </solidFill>
-                <latin typeface="Calibri"/>
-              </rPr>
-              <t/>
-            </r>
-          </p>
-          <p>
-            <pPr algn="l">
-              <lnSpc>
-                <spcPct val="125000"/>
-              </lnSpc>
-            </pPr>
-            <r>
-              <rPr sz="2618" b="0" i="0">
-                <solidFill>
-                  <srgbClr val="2A2A2A"/>
-                </solidFill>
-                <latin typeface="Calibri"/>
-              </rPr>
-              <t>We rank-average their outputs into a single continuous</t>
-            </r>
-          </p>
-          <p>
-            <pPr algn="l">
-              <lnSpc>
-                <spcPct val="125000"/>
-              </lnSpc>
-            </pPr>
-            <r>
-              <rPr sz="2618" b="0" i="0">
-                <solidFill>
-                  <srgbClr val="2A2A2A"/>
-                </solidFill>
-                <latin typeface="Calibri"/>
-              </rPr>
-              <t>suspicion score in [0, 1], replacing the legacy three-detector</t>
-            </r>
-          </p>
-          <p>
-            <pPr algn="l">
-              <lnSpc>
-                <spcPct val="125000"/>
-              </lnSpc>
-            </pPr>
-            <r>
-              <rPr sz="2618" b="0" i="0">
-                <solidFill>
-                  <srgbClr val="2A2A2A"/>
-                </solidFill>
-                <latin typeface="Calibri"/>
-              </rPr>
-              <t>yes/no vote.</t>
-            </r>
-          </p>
-          <p>
-            <pPr algn="l">
-              <lnSpc>
-                <spcPct val="125000"/>
-              </lnSpc>
-            </pPr>
-            <r>
-              <rPr sz="2618" b="0" i="0">
-                <solidFill>
-                  <srgbClr val="2A2A2A"/>
-                </solidFill>
-                <latin typeface="Calibri"/>
-              </rPr>
-              <t/>
-            </r>
-          </p>
-          <p>
-            <pPr algn="l">
-              <lnSpc>
-                <spcPct val="125000"/>
-              </lnSpc>
-            </pPr>
-            <r>
-              <rPr sz="2618" b="0" i="0">
-                <solidFill>
-                  <srgbClr val="2A2A2A"/>
-                </solidFill>
-                <latin typeface="Calibri"/>
-              </rPr>
-              <t>Layer 2. Logistic regression (L2-regularized) fit on n=14</t>
-            </r>
-          </p>
-          <p>
-            <pPr algn="l">
-              <lnSpc>
-                <spcPct val="125000"/>
-              </lnSpc>
-            </pPr>
-            <r>
-              <rPr sz="2618" b="0" i="0">
-                <solidFill>
-                  <srgbClr val="2A2A2A"/>
-                </solidFill>
-                <latin typeface="Calibri"/>
-              </rPr>
-              <t>hand-validated tokens, mapping suspicious-behavior features</t>
-            </r>
-          </p>
-          <p>
-            <pPr algn="l">
-              <lnSpc>
-                <spcPct val="125000"/>
-              </lnSpc>
-            </pPr>
-            <r>
-              <rPr sz="2618" b="0" i="0">
-                <solidFill>
-                  <srgbClr val="2A2A2A"/>
-                </solidFill>
-                <latin typeface="Calibri"/>
-              </rPr>
-              <t>to P(fraud). Evaluated with leave-one-out cross-validation.</t>
-            </r>
-          </p>
-        </p:txBody>
-      </p:sp>
-      <p:sp>
-        <p:nvSpPr>
-          <p:cNvPr id="18" name="TextBox 17"/>
-          <p:cNvSpPr txBox="1"/>
-          <p:nvPr/>
-        </p:nvSpPr>
-        <p:spPr>
-          <xfrm>
-            <off x="36875258" y="5486400"/>
-            <ext cx="17090967" cy="897774"/>
-          </xfrm>
-          <prstGeom prst="rect">
-            <avLst/>
-          </prstGeom>
-          <noFill/>
-        </p:spPr>
-        <p:txBody>
-          <bodyPr wrap="square" anchor="t">
-            <spAutoFit/>
-          </bodyPr>
-          <lstStyle/>
-          <p>
-            <pPr algn="l">
-              <lnSpc>
-                <spcPct val="115000"/>
-              </lnSpc>
-            </pPr>
-            <r>
-              <rPr sz="4581" b="1" i="0">
-                <solidFill>
-                  <srgbClr val="A51C30"/>
-                </solidFill>
-                <latin typeface="Calibri"/>
-              </rPr>
-              <t>RESULTS</t>
-            </r>
-          </p>
-        </p:txBody>
-      </p:sp>
-      <p:sp>
-        <p:nvSpPr>
-          <p:cNvPr id="19" name="Rectangle 18"/>
-          <p:cNvSpPr/>
-          <p:nvPr/>
-        </p:nvSpPr>
-        <p:spPr>
-          <xfrm>
-            <off x="36875258" y="6483927"/>
-            <ext cx="5981838" cy="39901"/>
-          </xfrm>
-          <prstGeom prst="rect">
-            <avLst/>
-          </prstGeom>
-          <solidFill>
-            <srgbClr val="A51C30"/>
-          </solidFill>
-          <ln>
-            <noFill/>
-          </ln>
-          <effectLst/>
-        </p:spPr>
-        <p:style>
-          <lnRef idx="1">
-            <schemeClr val="accent1"/>
-          </lnRef>
-          <fillRef idx="3">
-            <schemeClr val="accent1"/>
-          </fillRef>
-          <effectRef idx="2">
-            <schemeClr val="accent1"/>
-          </effectRef>
-          <fontRef idx="minor">
-            <schemeClr val="lt1"/>
-          </fontRef>
-        </p:style>
-        <p:txBody>
-          <bodyPr rtlCol="0" anchor="ctr"/>
-          <lstStyle/>
-          <p>
-            <pPr algn="ctr"/>
-          </p>
-        </p:txBody>
-      </p:sp>
-      <p:sp>
-        <p:nvSpPr>
-          <p:cNvPr id="20" name="Rounded Rectangle 19"/>
-          <p:cNvSpPr/>
-          <p:nvPr/>
-        </p:nvSpPr>
-        <p:spPr>
-          <xfrm>
-            <off x="36875258" y="6882938"/>
-            <ext cx="17090967" cy="3192087"/>
-          </xfrm>
-          <prstGeom prst="roundRect">
-            <avLst>
-              <gd name="adj" fmla="val 6000"/>
-            </avLst>
-          </prstGeom>
-          <solidFill>
-            <srgbClr val="F5F5F5"/>
-          </solidFill>
-          <ln w="9525">
-            <solidFill>
-              <srgbClr val="D8D8D8"/>
-            </solidFill>
-          </ln>
-          <effectLst/>
-        </p:spPr>
-        <p:style>
-          <lnRef idx="1">
-            <schemeClr val="accent1"/>
-          </lnRef>
-          <fillRef idx="3">
-            <schemeClr val="accent1"/>
-          </fillRef>
-          <effectRef idx="2">
-            <schemeClr val="accent1"/>
-          </effectRef>
-          <fontRef idx="minor">
-            <schemeClr val="lt1"/>
-          </fontRef>
-        </p:style>
-        <p:txBody>
-          <bodyPr rtlCol="0" anchor="ctr"/>
-          <lstStyle/>
-          <p>
-            <pPr algn="ctr"/>
-          </p>
-        </p:txBody>
-      </p:sp>
-      <p:sp>
-        <p:nvSpPr>
-          <p:cNvPr id="21" name="TextBox 20"/>
-          <p:cNvSpPr txBox="1"/>
-          <p:nvPr/>
-        </p:nvSpPr>
-        <p:spPr>
-          <xfrm>
-            <off x="36875258" y="7032567"/>
-            <ext cx="17090967" cy="1596043"/>
-          </xfrm>
-          <prstGeom prst="rect">
-            <avLst/>
-          </prstGeom>
-          <noFill/>
-        </p:spPr>
-        <p:txBody>
-          <bodyPr wrap="square" anchor="t">
-            <spAutoFit/>
-          </bodyPr>
-          <lstStyle/>
-          <p>
-            <pPr algn="ctr">
-              <lnSpc>
-                <spcPct val="115000"/>
-              </lnSpc>
-            </pPr>
-            <r>
-              <rPr sz="10472" b="1" i="0">
-                <solidFill>
-                  <srgbClr val="A51C30"/>
-                </solidFill>
-                <latin typeface="Georgia"/>
-              </rPr>
-              <t>6 / 6</t>
-            </r>
-          </p>
-        </p:txBody>
-      </p:sp>
-      <p:sp>
-        <p:nvSpPr>
-          <p:cNvPr id="22" name="TextBox 21"/>
-          <p:cNvSpPr txBox="1"/>
-          <p:nvPr/>
-        </p:nvSpPr>
-        <p:spPr>
-          <xfrm>
-            <off x="36875258" y="8778240"/>
-            <ext cx="17090967" cy="1197032"/>
-          </xfrm>
-          <prstGeom prst="rect">
-            <avLst/>
-          </prstGeom>
-          <noFill/>
-        </p:spPr>
-        <p:txBody>
-          <bodyPr wrap="square" anchor="t">
-            <spAutoFit/>
-          </bodyPr>
-          <lstStyle/>
-          <p>
-            <pPr algn="ctr">
-              <lnSpc>
-                <spcPct val="120000"/>
-              </lnSpc>
-            </pPr>
-            <r>
-              <rPr sz="2400" b="0" i="1">
-                <solidFill>
-                  <srgbClr val="2A2A2A"/>
-                </solidFill>
-                <latin typeface="Calibri"/>
-              </rPr>
-              <t>known frauds recovered at the p90 suspicion cutoff.</t>
-            </r>
-          </p>
-          <p>
-            <pPr algn="ctr">
-              <lnSpc>
-                <spcPct val="120000"/>
-              </lnSpc>
-            </pPr>
-            <r>
-              <rPr sz="2400" b="0" i="1">
-                <solidFill>
-                  <srgbClr val="2A2A2A"/>
-                </solidFill>
-                <latin typeface="Calibri"/>
-              </rPr>
-              <t>The legacy three-vote consensus recovered 1 of 6.</t>
-            </r>
-          </p>
+          <a:bodyPr rtlCol="0" anchor="ctr"/>
+          <a:lstStyle/>
+          <a:p>
+            <a:pPr algn="ctr"/>
+          </a:p>
         </p:txBody>
       </p:sp>
       <p:pic>
         <p:nvPicPr>
-          <p:cNvPr id="23" name="Picture 22" descr="baseline_comparison.png"/>
+          <p:cNvPr id="3" name="Picture 2" descr="harvard-shield.png"/>
           <p:cNvPicPr>
-            <picLocks noChangeAspect="1"/>
+            <a:picLocks noChangeAspect="1"/>
           </p:cNvPicPr>
           <p:nvPr/>
         </p:nvPicPr>
         <p:blipFill>
-          <blip ns2:embed="rId2"/>
-          <stretch>
-            <fillRect/>
-          </stretch>
+          <a:blip r:embed="rId2"/>
+          <a:stretch>
+            <a:fillRect/>
+          </a:stretch>
         </p:blipFill>
         <p:spPr>
-          <xfrm>
-            <off x="36875258" y="10474036"/>
-            <ext cx="17090967" cy="6483927"/>
-          </xfrm>
-          <prstGeom prst="rect">
-            <avLst/>
-          </prstGeom>
+          <a:xfrm>
+            <a:off x="822960" y="548640"/>
+            <a:ext cx="2926080" cy="3291840"/>
+          </a:xfrm>
+          <a:prstGeom prst="rect">
+            <a:avLst/>
+          </a:prstGeom>
         </p:spPr>
       </p:pic>
-      <p:sp>
-        <p:nvSpPr>
-          <p:cNvPr id="24" name="TextBox 23"/>
-          <p:cNvSpPr txBox="1"/>
-          <p:nvPr/>
-        </p:nvSpPr>
-        <p:spPr>
-          <xfrm>
-            <off x="36875258" y="17007840"/>
-            <ext cx="17090967" cy="798021"/>
-          </xfrm>
-          <prstGeom prst="rect">
-            <avLst/>
-          </prstGeom>
-          <noFill/>
-        </p:spPr>
-        <p:txBody>
-          <bodyPr wrap="square" anchor="t">
-            <spAutoFit/>
-          </bodyPr>
-          <lstStyle/>
-          <p>
-            <pPr algn="ctr">
-              <lnSpc>
-                <spcPct val="115000"/>
-              </lnSpc>
-            </pPr>
-            <r>
-              <rPr sz="2400" b="0" i="1">
-                <solidFill>
-                  <srgbClr val="2A2A2A"/>
-                </solidFill>
-                <latin typeface="Calibri"/>
-              </rPr>
-              <t>Fig. 1.  Fraud recall on the validated subset (n=6 fraud, 8 non-fraud</t>
-            </r>
-          </p>
-          <p>
-            <pPr algn="ctr">
-              <lnSpc>
-                <spcPct val="115000"/>
-              </lnSpc>
-            </pPr>
-            <r>
-              <rPr sz="2400" b="0" i="1">
-                <solidFill>
-                  <srgbClr val="2A2A2A"/>
-                </solidFill>
-                <latin typeface="Calibri"/>
-              </rPr>
-              <t>anomaly). Continuous suspicion score catches all known fraud where</t>
-            </r>
-          </p>
-          <p>
-            <pPr algn="ctr">
-              <lnSpc>
-                <spcPct val="115000"/>
-              </lnSpc>
-            </pPr>
-            <r>
-              <rPr sz="2400" b="0" i="1">
-                <solidFill>
-                  <srgbClr val="2A2A2A"/>
-                </solidFill>
-                <latin typeface="Calibri"/>
-              </rPr>
-              <t>the legacy consensus vote catches one.</t>
-            </r>
-          </p>
-        </p:txBody>
-      </p:sp>
       <p:pic>
         <p:nvPicPr>
-          <p:cNvPr id="25" name="Picture 24" descr="shap_global_importance.png"/>
+          <p:cNvPr id="4" name="Picture 3" descr="H_SEAS_logo_RGB.png"/>
           <p:cNvPicPr>
-            <picLocks noChangeAspect="1"/>
+            <a:picLocks noChangeAspect="1"/>
           </p:cNvPicPr>
           <p:nvPr/>
         </p:nvPicPr>
         <p:blipFill>
-          <blip ns2:embed="rId3"/>
-          <stretch>
-            <fillRect/>
-          </stretch>
+          <a:blip r:embed="rId3"/>
+          <a:stretch>
+            <a:fillRect/>
+          </a:stretch>
         </p:blipFill>
         <p:spPr>
-          <xfrm>
-            <off x="36875258" y="18554007"/>
-            <ext cx="17090967" cy="5187141"/>
-          </xfrm>
-          <prstGeom prst="rect">
-            <avLst/>
-          </prstGeom>
+          <a:xfrm>
+            <a:off x="46542960" y="548640"/>
+            <a:ext cx="2926080" cy="3291840"/>
+          </a:xfrm>
+          <a:prstGeom prst="rect">
+            <a:avLst/>
+          </a:prstGeom>
         </p:spPr>
       </p:pic>
+      <p:sp>
+        <p:nvSpPr>
+          <p:cNvPr id="5" name="TextBox 4"/>
+          <p:cNvSpPr txBox="1"/>
+          <p:nvPr/>
+        </p:nvSpPr>
+        <p:spPr>
+          <a:xfrm>
+            <a:off x="4114800" y="548640"/>
+            <a:ext cx="42062400" cy="2377440"/>
+          </a:xfrm>
+          <a:prstGeom prst="rect">
+            <a:avLst/>
+          </a:prstGeom>
+          <a:noFill/>
+        </p:spPr>
+        <p:txBody>
+          <a:bodyPr wrap="square" anchor="t">
+            <a:spAutoFit/>
+          </a:bodyPr>
+          <a:lstStyle/>
+          <a:p>
+            <a:pPr algn="ctr">
+              <a:lnSpc>
+                <a:spcPct val="105000"/>
+              </a:lnSpc>
+            </a:pPr>
+            <a:r>
+              <a:rPr sz="5600" b="1" i="0">
+                <a:solidFill>
+                  <a:srgbClr val="A51C30"/>
+                </a:solidFill>
+                <a:latin typeface="Georgia"/>
+              </a:rPr>
+              <a:t>Detecting crypto fraud without labels:</a:t>
+            </a:r>
+          </a:p>
+          <a:p>
+            <a:pPr algn="ctr">
+              <a:lnSpc>
+                <a:spcPct val="105000"/>
+              </a:lnSpc>
+            </a:pPr>
+            <a:r>
+              <a:rPr sz="5600" b="1" i="0">
+                <a:solidFill>
+                  <a:srgbClr val="A51C30"/>
+                </a:solidFill>
+                <a:latin typeface="Georgia"/>
+              </a:rPr>
+              <a:t>14 of 15 known rug pulls recovered from 4,334 Ethereum tokens.</a:t>
+            </a:r>
+          </a:p>
+        </p:txBody>
+      </p:sp>
+      <p:sp>
+        <p:nvSpPr>
+          <p:cNvPr id="6" name="TextBox 5"/>
+          <p:cNvSpPr txBox="1"/>
+          <p:nvPr/>
+        </p:nvSpPr>
+        <p:spPr>
+          <a:xfrm>
+            <a:off x="4114800" y="2926080"/>
+            <a:ext cx="42062400" cy="640080"/>
+          </a:xfrm>
+          <a:prstGeom prst="rect">
+            <a:avLst/>
+          </a:prstGeom>
+          <a:noFill/>
+        </p:spPr>
+        <p:txBody>
+          <a:bodyPr wrap="square" anchor="t">
+            <a:spAutoFit/>
+          </a:bodyPr>
+          <a:lstStyle/>
+          <a:p>
+            <a:pPr algn="ctr">
+              <a:lnSpc>
+                <a:spcPct val="120000"/>
+              </a:lnSpc>
+            </a:pPr>
+            <a:r>
+              <a:rPr sz="2800" b="0" i="0">
+                <a:solidFill>
+                  <a:srgbClr val="2A2A2A"/>
+                </a:solidFill>
+                <a:latin typeface="Georgia"/>
+              </a:rPr>
+              <a:t>Gillian Schriever  ·  Jiahui (Cecilia) Cai  ·  Zhilin Chen  ·  Jinghan Huang</a:t>
+            </a:r>
+          </a:p>
+        </p:txBody>
+      </p:sp>
+      <p:sp>
+        <p:nvSpPr>
+          <p:cNvPr id="7" name="TextBox 6"/>
+          <p:cNvSpPr txBox="1"/>
+          <p:nvPr/>
+        </p:nvSpPr>
+        <p:spPr>
+          <a:xfrm>
+            <a:off x="4114800" y="3566160"/>
+            <a:ext cx="42062400" cy="548640"/>
+          </a:xfrm>
+          <a:prstGeom prst="rect">
+            <a:avLst/>
+          </a:prstGeom>
+          <a:noFill/>
+        </p:spPr>
+        <p:txBody>
+          <a:bodyPr wrap="square" anchor="t">
+            <a:spAutoFit/>
+          </a:bodyPr>
+          <a:lstStyle/>
+          <a:p>
+            <a:pPr algn="ctr">
+              <a:lnSpc>
+                <a:spcPct val="120000"/>
+              </a:lnSpc>
+            </a:pPr>
+            <a:r>
+              <a:rPr sz="2200" b="0" i="1">
+                <a:solidFill>
+                  <a:srgbClr val="2A2A2A"/>
+                </a:solidFill>
+                <a:latin typeface="Georgia"/>
+              </a:rPr>
+              <a:t>Harvard John A. Paulson School of Engineering and Applied Sciences  —  AC297r Capstone, Spring 2026</a:t>
+            </a:r>
+          </a:p>
+        </p:txBody>
+      </p:sp>
+      <p:sp>
+        <p:nvSpPr>
+          <p:cNvPr id="8" name="Rectangle 7"/>
+          <p:cNvSpPr/>
+          <p:nvPr/>
+        </p:nvSpPr>
+        <p:spPr>
+          <a:xfrm>
+            <a:off x="0" y="4389120"/>
+            <a:ext cx="50292000" cy="36576"/>
+          </a:xfrm>
+          <a:prstGeom prst="rect">
+            <a:avLst/>
+          </a:prstGeom>
+          <a:solidFill>
+            <a:srgbClr val="A51C30"/>
+          </a:solidFill>
+          <a:ln>
+            <a:noFill/>
+          </a:ln>
+          <a:effectLst/>
+        </p:spPr>
+        <p:style>
+          <a:lnRef idx="1">
+            <a:schemeClr val="accent1"/>
+          </a:lnRef>
+          <a:fillRef idx="3">
+            <a:schemeClr val="accent1"/>
+          </a:fillRef>
+          <a:effectRef idx="2">
+            <a:schemeClr val="accent1"/>
+          </a:effectRef>
+          <a:fontRef idx="minor">
+            <a:schemeClr val="lt1"/>
+          </a:fontRef>
+        </p:style>
+        <p:txBody>
+          <a:bodyPr rtlCol="0" anchor="ctr"/>
+          <a:lstStyle/>
+          <a:p>
+            <a:pPr algn="ctr"/>
+          </a:p>
+        </p:txBody>
+      </p:sp>
+      <p:sp>
+        <p:nvSpPr>
+          <p:cNvPr id="9" name="TextBox 8"/>
+          <p:cNvSpPr txBox="1"/>
+          <p:nvPr/>
+        </p:nvSpPr>
+        <p:spPr>
+          <a:xfrm>
+            <a:off x="822960" y="5029200"/>
+            <a:ext cx="15666720" cy="822960"/>
+          </a:xfrm>
+          <a:prstGeom prst="rect">
+            <a:avLst/>
+          </a:prstGeom>
+          <a:noFill/>
+        </p:spPr>
+        <p:txBody>
+          <a:bodyPr wrap="square" anchor="t">
+            <a:spAutoFit/>
+          </a:bodyPr>
+          <a:lstStyle/>
+          <a:p>
+            <a:pPr algn="l">
+              <a:lnSpc>
+                <a:spcPct val="120000"/>
+              </a:lnSpc>
+            </a:pPr>
+            <a:r>
+              <a:rPr sz="4200" b="1" i="0">
+                <a:solidFill>
+                  <a:srgbClr val="A51C30"/>
+                </a:solidFill>
+                <a:latin typeface="Calibri"/>
+              </a:rPr>
+              <a:t>THE QUESTION</a:t>
+            </a:r>
+          </a:p>
+        </p:txBody>
+      </p:sp>
+      <p:sp>
+        <p:nvSpPr>
+          <p:cNvPr id="10" name="Rectangle 9"/>
+          <p:cNvSpPr/>
+          <p:nvPr/>
+        </p:nvSpPr>
+        <p:spPr>
+          <a:xfrm>
+            <a:off x="822960" y="5943600"/>
+            <a:ext cx="5483352" cy="36576"/>
+          </a:xfrm>
+          <a:prstGeom prst="rect">
+            <a:avLst/>
+          </a:prstGeom>
+          <a:solidFill>
+            <a:srgbClr val="A51C30"/>
+          </a:solidFill>
+          <a:ln>
+            <a:noFill/>
+          </a:ln>
+          <a:effectLst/>
+        </p:spPr>
+        <p:style>
+          <a:lnRef idx="1">
+            <a:schemeClr val="accent1"/>
+          </a:lnRef>
+          <a:fillRef idx="3">
+            <a:schemeClr val="accent1"/>
+          </a:fillRef>
+          <a:effectRef idx="2">
+            <a:schemeClr val="accent1"/>
+          </a:effectRef>
+          <a:fontRef idx="minor">
+            <a:schemeClr val="lt1"/>
+          </a:fontRef>
+        </p:style>
+        <p:txBody>
+          <a:bodyPr rtlCol="0" anchor="ctr"/>
+          <a:lstStyle/>
+          <a:p>
+            <a:pPr algn="ctr"/>
+          </a:p>
+        </p:txBody>
+      </p:sp>
+      <p:sp>
+        <p:nvSpPr>
+          <p:cNvPr id="11" name="TextBox 10"/>
+          <p:cNvSpPr txBox="1"/>
+          <p:nvPr/>
+        </p:nvSpPr>
+        <p:spPr>
+          <a:xfrm>
+            <a:off x="822960" y="6309360"/>
+            <a:ext cx="15666720" cy="2743200"/>
+          </a:xfrm>
+          <a:prstGeom prst="rect">
+            <a:avLst/>
+          </a:prstGeom>
+          <a:noFill/>
+        </p:spPr>
+        <p:txBody>
+          <a:bodyPr wrap="square" anchor="t">
+            <a:spAutoFit/>
+          </a:bodyPr>
+          <a:lstStyle/>
+          <a:p>
+            <a:pPr algn="l">
+              <a:lnSpc>
+                <a:spcPct val="115000"/>
+              </a:lnSpc>
+            </a:pPr>
+            <a:r>
+              <a:rPr sz="3000" b="1" i="0">
+                <a:solidFill>
+                  <a:srgbClr val="2A2A2A"/>
+                </a:solidFill>
+                <a:latin typeface="Calibri"/>
+              </a:rPr>
+              <a:t>Can we detect crypto fraud without any labeled data?</a:t>
+            </a:r>
+          </a:p>
+        </p:txBody>
+      </p:sp>
+      <p:sp>
+        <p:nvSpPr>
+          <p:cNvPr id="12" name="TextBox 11"/>
+          <p:cNvSpPr txBox="1"/>
+          <p:nvPr/>
+        </p:nvSpPr>
+        <p:spPr>
+          <a:xfrm>
+            <a:off x="822960" y="8869680"/>
+            <a:ext cx="15666720" cy="9601200"/>
+          </a:xfrm>
+          <a:prstGeom prst="rect">
+            <a:avLst/>
+          </a:prstGeom>
+          <a:noFill/>
+        </p:spPr>
+        <p:txBody>
+          <a:bodyPr wrap="square" anchor="t">
+            <a:spAutoFit/>
+          </a:bodyPr>
+          <a:lstStyle/>
+          <a:p>
+            <a:pPr algn="l">
+              <a:lnSpc>
+                <a:spcPct val="125000"/>
+              </a:lnSpc>
+            </a:pPr>
+            <a:r>
+              <a:rPr sz="2400" b="0" i="0">
+                <a:solidFill>
+                  <a:srgbClr val="2A2A2A"/>
+                </a:solidFill>
+                <a:latin typeface="Calibri"/>
+              </a:rPr>
+              <a:t>Fraud labels in crypto are rare, slow to publish, and biased</a:t>
+            </a:r>
+          </a:p>
+          <a:p>
+            <a:pPr algn="l">
+              <a:lnSpc>
+                <a:spcPct val="125000"/>
+              </a:lnSpc>
+            </a:pPr>
+            <a:r>
+              <a:rPr sz="2400" b="0" i="0">
+                <a:solidFill>
+                  <a:srgbClr val="2A2A2A"/>
+                </a:solidFill>
+                <a:latin typeface="Calibri"/>
+              </a:rPr>
+              <a:t>toward high-profile cases. Supervised classifiers trained on</a:t>
+            </a:r>
+          </a:p>
+          <a:p>
+            <a:pPr algn="l">
+              <a:lnSpc>
+                <a:spcPct val="125000"/>
+              </a:lnSpc>
+            </a:pPr>
+            <a:r>
+              <a:rPr sz="2400" b="0" i="0">
+                <a:solidFill>
+                  <a:srgbClr val="2A2A2A"/>
+                </a:solidFill>
+                <a:latin typeface="Calibri"/>
+              </a:rPr>
+              <a:t>them don't generalize — the attacks evolve faster than the</a:t>
+            </a:r>
+          </a:p>
+          <a:p>
+            <a:pPr algn="l">
+              <a:lnSpc>
+                <a:spcPct val="125000"/>
+              </a:lnSpc>
+            </a:pPr>
+            <a:r>
+              <a:rPr sz="2400" b="0" i="0">
+                <a:solidFill>
+                  <a:srgbClr val="2A2A2A"/>
+                </a:solidFill>
+                <a:latin typeface="Calibri"/>
+              </a:rPr>
+              <a:t>labels.</a:t>
+            </a:r>
+          </a:p>
+          <a:p>
+            <a:pPr algn="l">
+              <a:lnSpc>
+                <a:spcPct val="125000"/>
+              </a:lnSpc>
+            </a:pPr>
+            <a:r>
+              <a:rPr sz="2400" b="0" i="0">
+                <a:solidFill>
+                  <a:srgbClr val="2A2A2A"/>
+                </a:solidFill>
+                <a:latin typeface="Calibri"/>
+              </a:rPr>
+              <a:t/>
+            </a:r>
+          </a:p>
+          <a:p>
+            <a:pPr algn="l">
+              <a:lnSpc>
+                <a:spcPct val="125000"/>
+              </a:lnSpc>
+            </a:pPr>
+            <a:r>
+              <a:rPr sz="2400" b="0" i="0">
+                <a:solidFill>
+                  <a:srgbClr val="2A2A2A"/>
+                </a:solidFill>
+                <a:latin typeface="Calibri"/>
+              </a:rPr>
+              <a:t>We build a two-layer unsupervised pipeline:</a:t>
+            </a:r>
+          </a:p>
+          <a:p>
+            <a:pPr algn="l">
+              <a:lnSpc>
+                <a:spcPct val="125000"/>
+              </a:lnSpc>
+            </a:pPr>
+            <a:r>
+              <a:rPr sz="2400" b="0" i="0">
+                <a:solidFill>
+                  <a:srgbClr val="2A2A2A"/>
+                </a:solidFill>
+                <a:latin typeface="Calibri"/>
+              </a:rPr>
+              <a:t/>
+            </a:r>
+          </a:p>
+          <a:p>
+            <a:pPr algn="l">
+              <a:lnSpc>
+                <a:spcPct val="125000"/>
+              </a:lnSpc>
+            </a:pPr>
+            <a:r>
+              <a:rPr sz="2400" b="0" i="0">
+                <a:solidFill>
+                  <a:srgbClr val="2A2A2A"/>
+                </a:solidFill>
+                <a:latin typeface="Calibri"/>
+              </a:rPr>
+              <a:t>①  Flag tokens whose on-chain trading behavior looks</a:t>
+            </a:r>
+          </a:p>
+          <a:p>
+            <a:pPr algn="l">
+              <a:lnSpc>
+                <a:spcPct val="125000"/>
+              </a:lnSpc>
+            </a:pPr>
+            <a:r>
+              <a:rPr sz="2400" b="0" i="0">
+                <a:solidFill>
+                  <a:srgbClr val="2A2A2A"/>
+                </a:solidFill>
+                <a:latin typeface="Calibri"/>
+              </a:rPr>
+              <a:t>     statistically unusual.</a:t>
+            </a:r>
+          </a:p>
+          <a:p>
+            <a:pPr algn="l">
+              <a:lnSpc>
+                <a:spcPct val="125000"/>
+              </a:lnSpc>
+            </a:pPr>
+            <a:r>
+              <a:rPr sz="2400" b="0" i="0">
+                <a:solidFill>
+                  <a:srgbClr val="2A2A2A"/>
+                </a:solidFill>
+                <a:latin typeface="Calibri"/>
+              </a:rPr>
+              <a:t/>
+            </a:r>
+          </a:p>
+          <a:p>
+            <a:pPr algn="l">
+              <a:lnSpc>
+                <a:spcPct val="125000"/>
+              </a:lnSpc>
+            </a:pPr>
+            <a:r>
+              <a:rPr sz="2400" b="0" i="0">
+                <a:solidFill>
+                  <a:srgbClr val="2A2A2A"/>
+                </a:solidFill>
+                <a:latin typeface="Calibri"/>
+              </a:rPr>
+              <a:t>②  Estimate how likely that unusual behavior is to be</a:t>
+            </a:r>
+          </a:p>
+          <a:p>
+            <a:pPr algn="l">
+              <a:lnSpc>
+                <a:spcPct val="125000"/>
+              </a:lnSpc>
+            </a:pPr>
+            <a:r>
+              <a:rPr sz="2400" b="0" i="0">
+                <a:solidFill>
+                  <a:srgbClr val="2A2A2A"/>
+                </a:solidFill>
+                <a:latin typeface="Calibri"/>
+              </a:rPr>
+              <a:t>     intentional fraud (vs. a hack, bug, or large legitimate</a:t>
+            </a:r>
+          </a:p>
+          <a:p>
+            <a:pPr algn="l">
+              <a:lnSpc>
+                <a:spcPct val="125000"/>
+              </a:lnSpc>
+            </a:pPr>
+            <a:r>
+              <a:rPr sz="2400" b="0" i="0">
+                <a:solidFill>
+                  <a:srgbClr val="2A2A2A"/>
+                </a:solidFill>
+                <a:latin typeface="Calibri"/>
+              </a:rPr>
+              <a:t>     event).</a:t>
+            </a:r>
+          </a:p>
+        </p:txBody>
+      </p:sp>
+      <p:sp>
+        <p:nvSpPr>
+          <p:cNvPr id="13" name="TextBox 12"/>
+          <p:cNvSpPr txBox="1"/>
+          <p:nvPr/>
+        </p:nvSpPr>
+        <p:spPr>
+          <a:xfrm>
+            <a:off x="17312640" y="5029200"/>
+            <a:ext cx="15666720" cy="822960"/>
+          </a:xfrm>
+          <a:prstGeom prst="rect">
+            <a:avLst/>
+          </a:prstGeom>
+          <a:noFill/>
+        </p:spPr>
+        <p:txBody>
+          <a:bodyPr wrap="square" anchor="t">
+            <a:spAutoFit/>
+          </a:bodyPr>
+          <a:lstStyle/>
+          <a:p>
+            <a:pPr algn="l">
+              <a:lnSpc>
+                <a:spcPct val="120000"/>
+              </a:lnSpc>
+            </a:pPr>
+            <a:r>
+              <a:rPr sz="4200" b="1" i="0">
+                <a:solidFill>
+                  <a:srgbClr val="A51C30"/>
+                </a:solidFill>
+                <a:latin typeface="Calibri"/>
+              </a:rPr>
+              <a:t>METHODS</a:t>
+            </a:r>
+          </a:p>
+        </p:txBody>
+      </p:sp>
+      <p:sp>
+        <p:nvSpPr>
+          <p:cNvPr id="14" name="Rectangle 13"/>
+          <p:cNvSpPr/>
+          <p:nvPr/>
+        </p:nvSpPr>
+        <p:spPr>
+          <a:xfrm>
+            <a:off x="17312640" y="5943600"/>
+            <a:ext cx="5483352" cy="36576"/>
+          </a:xfrm>
+          <a:prstGeom prst="rect">
+            <a:avLst/>
+          </a:prstGeom>
+          <a:solidFill>
+            <a:srgbClr val="A51C30"/>
+          </a:solidFill>
+          <a:ln>
+            <a:noFill/>
+          </a:ln>
+          <a:effectLst/>
+        </p:spPr>
+        <p:style>
+          <a:lnRef idx="1">
+            <a:schemeClr val="accent1"/>
+          </a:lnRef>
+          <a:fillRef idx="3">
+            <a:schemeClr val="accent1"/>
+          </a:fillRef>
+          <a:effectRef idx="2">
+            <a:schemeClr val="accent1"/>
+          </a:effectRef>
+          <a:fontRef idx="minor">
+            <a:schemeClr val="lt1"/>
+          </a:fontRef>
+        </p:style>
+        <p:txBody>
+          <a:bodyPr rtlCol="0" anchor="ctr"/>
+          <a:lstStyle/>
+          <a:p>
+            <a:pPr algn="ctr"/>
+          </a:p>
+        </p:txBody>
+      </p:sp>
+      <p:sp>
+        <p:nvSpPr>
+          <p:cNvPr id="15" name="TextBox 14"/>
+          <p:cNvSpPr txBox="1"/>
+          <p:nvPr/>
+        </p:nvSpPr>
+        <p:spPr>
+          <a:xfrm>
+            <a:off x="17312640" y="6309360"/>
+            <a:ext cx="15666720" cy="12344400"/>
+          </a:xfrm>
+          <a:prstGeom prst="rect">
+            <a:avLst/>
+          </a:prstGeom>
+          <a:noFill/>
+        </p:spPr>
+        <p:txBody>
+          <a:bodyPr wrap="square" anchor="t">
+            <a:spAutoFit/>
+          </a:bodyPr>
+          <a:lstStyle/>
+          <a:p>
+            <a:pPr algn="l">
+              <a:lnSpc>
+                <a:spcPct val="125000"/>
+              </a:lnSpc>
+            </a:pPr>
+            <a:r>
+              <a:rPr sz="2400" b="0" i="0">
+                <a:solidFill>
+                  <a:srgbClr val="2A2A2A"/>
+                </a:solidFill>
+                <a:latin typeface="Calibri"/>
+              </a:rPr>
+              <a:t>Data.  4,334 mid-cap ERC-20 tokens on Ethereum</a:t>
+            </a:r>
+          </a:p>
+          <a:p>
+            <a:pPr algn="l">
+              <a:lnSpc>
+                <a:spcPct val="125000"/>
+              </a:lnSpc>
+            </a:pPr>
+            <a:r>
+              <a:rPr sz="2400" b="0" i="0">
+                <a:solidFill>
+                  <a:srgbClr val="2A2A2A"/>
+                </a:solidFill>
+                <a:latin typeface="Calibri"/>
+              </a:rPr>
+              <a:t>(Dune Analytics, 365-day window, $1M–$1B annual volume).</a:t>
+            </a:r>
+          </a:p>
+          <a:p>
+            <a:pPr algn="l">
+              <a:lnSpc>
+                <a:spcPct val="125000"/>
+              </a:lnSpc>
+            </a:pPr>
+            <a:r>
+              <a:rPr sz="2400" b="0" i="0">
+                <a:solidFill>
+                  <a:srgbClr val="2A2A2A"/>
+                </a:solidFill>
+                <a:latin typeface="Calibri"/>
+              </a:rPr>
+              <a:t/>
+            </a:r>
+          </a:p>
+          <a:p>
+            <a:pPr algn="l">
+              <a:lnSpc>
+                <a:spcPct val="125000"/>
+              </a:lnSpc>
+            </a:pPr>
+            <a:r>
+              <a:rPr sz="2400" b="0" i="0">
+                <a:solidFill>
+                  <a:srgbClr val="2A2A2A"/>
+                </a:solidFill>
+                <a:latin typeface="Calibri"/>
+              </a:rPr>
+              <a:t>Features (6).  Volume spike ratio, peak daily volume, days</a:t>
+            </a:r>
+          </a:p>
+          <a:p>
+            <a:pPr algn="l">
+              <a:lnSpc>
+                <a:spcPct val="125000"/>
+              </a:lnSpc>
+            </a:pPr>
+            <a:r>
+              <a:rPr sz="2400" b="0" i="0">
+                <a:solidFill>
+                  <a:srgbClr val="2A2A2A"/>
+                </a:solidFill>
+                <a:latin typeface="Calibri"/>
+              </a:rPr>
+              <a:t>traded, max single-trade dominance, and two 24-hour post-</a:t>
+            </a:r>
+          </a:p>
+          <a:p>
+            <a:pPr algn="l">
+              <a:lnSpc>
+                <a:spcPct val="125000"/>
+              </a:lnSpc>
+            </a:pPr>
+            <a:r>
+              <a:rPr sz="2400" b="0" i="0">
+                <a:solidFill>
+                  <a:srgbClr val="2A2A2A"/>
+                </a:solidFill>
+                <a:latin typeface="Calibri"/>
+              </a:rPr>
+              <a:t>launch velocity features.</a:t>
+            </a:r>
+          </a:p>
+          <a:p>
+            <a:pPr algn="l">
+              <a:lnSpc>
+                <a:spcPct val="125000"/>
+              </a:lnSpc>
+            </a:pPr>
+            <a:r>
+              <a:rPr sz="2400" b="0" i="0">
+                <a:solidFill>
+                  <a:srgbClr val="2A2A2A"/>
+                </a:solidFill>
+                <a:latin typeface="Calibri"/>
+              </a:rPr>
+              <a:t/>
+            </a:r>
+          </a:p>
+          <a:p>
+            <a:pPr algn="l">
+              <a:lnSpc>
+                <a:spcPct val="125000"/>
+              </a:lnSpc>
+            </a:pPr>
+            <a:r>
+              <a:rPr sz="2400" b="0" i="0">
+                <a:solidFill>
+                  <a:srgbClr val="2A2A2A"/>
+                </a:solidFill>
+                <a:latin typeface="Calibri"/>
+              </a:rPr>
+              <a:t>Layer 1 — three independent detectors:</a:t>
+            </a:r>
+          </a:p>
+          <a:p>
+            <a:pPr algn="l">
+              <a:lnSpc>
+                <a:spcPct val="125000"/>
+              </a:lnSpc>
+            </a:pPr>
+            <a:r>
+              <a:rPr sz="2400" b="0" i="0">
+                <a:solidFill>
+                  <a:srgbClr val="2A2A2A"/>
+                </a:solidFill>
+                <a:latin typeface="Calibri"/>
+              </a:rPr>
+              <a:t>    •  Isolation Forest (tree-based outlier detection)</a:t>
+            </a:r>
+          </a:p>
+          <a:p>
+            <a:pPr algn="l">
+              <a:lnSpc>
+                <a:spcPct val="125000"/>
+              </a:lnSpc>
+            </a:pPr>
+            <a:r>
+              <a:rPr sz="2400" b="0" i="0">
+                <a:solidFill>
+                  <a:srgbClr val="2A2A2A"/>
+                </a:solidFill>
+                <a:latin typeface="Calibri"/>
+              </a:rPr>
+              <a:t>    •  DBSCAN (density clustering; keep the noise points)</a:t>
+            </a:r>
+          </a:p>
+          <a:p>
+            <a:pPr algn="l">
+              <a:lnSpc>
+                <a:spcPct val="125000"/>
+              </a:lnSpc>
+            </a:pPr>
+            <a:r>
+              <a:rPr sz="2400" b="0" i="0">
+                <a:solidFill>
+                  <a:srgbClr val="2A2A2A"/>
+                </a:solidFill>
+                <a:latin typeface="Calibri"/>
+              </a:rPr>
+              <a:t>    •  PCA + Mahalanobis distance</a:t>
+            </a:r>
+          </a:p>
+          <a:p>
+            <a:pPr algn="l">
+              <a:lnSpc>
+                <a:spcPct val="125000"/>
+              </a:lnSpc>
+            </a:pPr>
+            <a:r>
+              <a:rPr sz="2400" b="0" i="0">
+                <a:solidFill>
+                  <a:srgbClr val="2A2A2A"/>
+                </a:solidFill>
+                <a:latin typeface="Calibri"/>
+              </a:rPr>
+              <a:t/>
+            </a:r>
+          </a:p>
+          <a:p>
+            <a:pPr algn="l">
+              <a:lnSpc>
+                <a:spcPct val="125000"/>
+              </a:lnSpc>
+            </a:pPr>
+            <a:r>
+              <a:rPr sz="2400" b="0" i="0">
+                <a:solidFill>
+                  <a:srgbClr val="2A2A2A"/>
+                </a:solidFill>
+                <a:latin typeface="Calibri"/>
+              </a:rPr>
+              <a:t>Rank-averaged into a single continuous suspicion score</a:t>
+            </a:r>
+          </a:p>
+          <a:p>
+            <a:pPr algn="l">
+              <a:lnSpc>
+                <a:spcPct val="125000"/>
+              </a:lnSpc>
+            </a:pPr>
+            <a:r>
+              <a:rPr sz="2400" b="0" i="0">
+                <a:solidFill>
+                  <a:srgbClr val="2A2A2A"/>
+                </a:solidFill>
+                <a:latin typeface="Calibri"/>
+              </a:rPr>
+              <a:t>in [0, 1], replacing the legacy three-detector yes/no vote.</a:t>
+            </a:r>
+          </a:p>
+          <a:p>
+            <a:pPr algn="l">
+              <a:lnSpc>
+                <a:spcPct val="125000"/>
+              </a:lnSpc>
+            </a:pPr>
+            <a:r>
+              <a:rPr sz="2400" b="0" i="0">
+                <a:solidFill>
+                  <a:srgbClr val="2A2A2A"/>
+                </a:solidFill>
+                <a:latin typeface="Calibri"/>
+              </a:rPr>
+              <a:t/>
+            </a:r>
+          </a:p>
+          <a:p>
+            <a:pPr algn="l">
+              <a:lnSpc>
+                <a:spcPct val="125000"/>
+              </a:lnSpc>
+            </a:pPr>
+            <a:r>
+              <a:rPr sz="2400" b="0" i="0">
+                <a:solidFill>
+                  <a:srgbClr val="2A2A2A"/>
+                </a:solidFill>
+                <a:latin typeface="Calibri"/>
+              </a:rPr>
+              <a:t>Layer 2.  Logistic regression (L2-regularized) fit on</a:t>
+            </a:r>
+          </a:p>
+          <a:p>
+            <a:pPr algn="l">
+              <a:lnSpc>
+                <a:spcPct val="125000"/>
+              </a:lnSpc>
+            </a:pPr>
+            <a:r>
+              <a:rPr sz="2400" b="0" i="0">
+                <a:solidFill>
+                  <a:srgbClr val="2A2A2A"/>
+                </a:solidFill>
+                <a:latin typeface="Calibri"/>
+              </a:rPr>
+              <a:t>n = 144 hand- and web-validated tokens, mapping suspicious-</a:t>
+            </a:r>
+          </a:p>
+          <a:p>
+            <a:pPr algn="l">
+              <a:lnSpc>
+                <a:spcPct val="125000"/>
+              </a:lnSpc>
+            </a:pPr>
+            <a:r>
+              <a:rPr sz="2400" b="0" i="0">
+                <a:solidFill>
+                  <a:srgbClr val="2A2A2A"/>
+                </a:solidFill>
+                <a:latin typeface="Calibri"/>
+              </a:rPr>
+              <a:t>behavior features to P(fraud). Evaluated with leave-one-out</a:t>
+            </a:r>
+          </a:p>
+          <a:p>
+            <a:pPr algn="l">
+              <a:lnSpc>
+                <a:spcPct val="125000"/>
+              </a:lnSpc>
+            </a:pPr>
+            <a:r>
+              <a:rPr sz="2400" b="0" i="0">
+                <a:solidFill>
+                  <a:srgbClr val="2A2A2A"/>
+                </a:solidFill>
+                <a:latin typeface="Calibri"/>
+              </a:rPr>
+              <a:t>cross-validation.</a:t>
+            </a:r>
+          </a:p>
+        </p:txBody>
+      </p:sp>
+      <p:sp>
+        <p:nvSpPr>
+          <p:cNvPr id="16" name="TextBox 15"/>
+          <p:cNvSpPr txBox="1"/>
+          <p:nvPr/>
+        </p:nvSpPr>
+        <p:spPr>
+          <a:xfrm>
+            <a:off x="33802320" y="5029200"/>
+            <a:ext cx="15666720" cy="822960"/>
+          </a:xfrm>
+          <a:prstGeom prst="rect">
+            <a:avLst/>
+          </a:prstGeom>
+          <a:noFill/>
+        </p:spPr>
+        <p:txBody>
+          <a:bodyPr wrap="square" anchor="t">
+            <a:spAutoFit/>
+          </a:bodyPr>
+          <a:lstStyle/>
+          <a:p>
+            <a:pPr algn="l">
+              <a:lnSpc>
+                <a:spcPct val="120000"/>
+              </a:lnSpc>
+            </a:pPr>
+            <a:r>
+              <a:rPr sz="4200" b="1" i="0">
+                <a:solidFill>
+                  <a:srgbClr val="A51C30"/>
+                </a:solidFill>
+                <a:latin typeface="Calibri"/>
+              </a:rPr>
+              <a:t>RESULTS</a:t>
+            </a:r>
+          </a:p>
+        </p:txBody>
+      </p:sp>
+      <p:sp>
+        <p:nvSpPr>
+          <p:cNvPr id="17" name="Rectangle 16"/>
+          <p:cNvSpPr/>
+          <p:nvPr/>
+        </p:nvSpPr>
+        <p:spPr>
+          <a:xfrm>
+            <a:off x="33802320" y="5943600"/>
+            <a:ext cx="5483352" cy="36576"/>
+          </a:xfrm>
+          <a:prstGeom prst="rect">
+            <a:avLst/>
+          </a:prstGeom>
+          <a:solidFill>
+            <a:srgbClr val="A51C30"/>
+          </a:solidFill>
+          <a:ln>
+            <a:noFill/>
+          </a:ln>
+          <a:effectLst/>
+        </p:spPr>
+        <p:style>
+          <a:lnRef idx="1">
+            <a:schemeClr val="accent1"/>
+          </a:lnRef>
+          <a:fillRef idx="3">
+            <a:schemeClr val="accent1"/>
+          </a:fillRef>
+          <a:effectRef idx="2">
+            <a:schemeClr val="accent1"/>
+          </a:effectRef>
+          <a:fontRef idx="minor">
+            <a:schemeClr val="lt1"/>
+          </a:fontRef>
+        </p:style>
+        <p:txBody>
+          <a:bodyPr rtlCol="0" anchor="ctr"/>
+          <a:lstStyle/>
+          <a:p>
+            <a:pPr algn="ctr"/>
+          </a:p>
+        </p:txBody>
+      </p:sp>
+      <p:sp>
+        <p:nvSpPr>
+          <p:cNvPr id="18" name="Rounded Rectangle 17"/>
+          <p:cNvSpPr/>
+          <p:nvPr/>
+        </p:nvSpPr>
+        <p:spPr>
+          <a:xfrm>
+            <a:off x="33802320" y="6309360"/>
+            <a:ext cx="15666720" cy="2926080"/>
+          </a:xfrm>
+          <a:prstGeom prst="roundRect">
+            <a:avLst>
+              <a:gd name="adj" fmla="val 6000"/>
+            </a:avLst>
+          </a:prstGeom>
+          <a:solidFill>
+            <a:srgbClr val="F5F5F5"/>
+          </a:solidFill>
+          <a:ln w="9525">
+            <a:solidFill>
+              <a:srgbClr val="D8D8D8"/>
+            </a:solidFill>
+          </a:ln>
+          <a:effectLst/>
+        </p:spPr>
+        <p:style>
+          <a:lnRef idx="1">
+            <a:schemeClr val="accent1"/>
+          </a:lnRef>
+          <a:fillRef idx="3">
+            <a:schemeClr val="accent1"/>
+          </a:fillRef>
+          <a:effectRef idx="2">
+            <a:schemeClr val="accent1"/>
+          </a:effectRef>
+          <a:fontRef idx="minor">
+            <a:schemeClr val="lt1"/>
+          </a:fontRef>
+        </p:style>
+        <p:txBody>
+          <a:bodyPr rtlCol="0" anchor="ctr"/>
+          <a:lstStyle/>
+          <a:p>
+            <a:pPr algn="ctr"/>
+          </a:p>
+        </p:txBody>
+      </p:sp>
+      <p:sp>
+        <p:nvSpPr>
+          <p:cNvPr id="19" name="TextBox 18"/>
+          <p:cNvSpPr txBox="1"/>
+          <p:nvPr/>
+        </p:nvSpPr>
+        <p:spPr>
+          <a:xfrm>
+            <a:off x="33802320" y="6446520"/>
+            <a:ext cx="15666720" cy="1463040"/>
+          </a:xfrm>
+          <a:prstGeom prst="rect">
+            <a:avLst/>
+          </a:prstGeom>
+          <a:noFill/>
+        </p:spPr>
+        <p:txBody>
+          <a:bodyPr wrap="square" anchor="t">
+            <a:spAutoFit/>
+          </a:bodyPr>
+          <a:lstStyle/>
+          <a:p>
+            <a:pPr algn="ctr">
+              <a:lnSpc>
+                <a:spcPct val="120000"/>
+              </a:lnSpc>
+            </a:pPr>
+            <a:r>
+              <a:rPr sz="9600" b="1" i="0">
+                <a:solidFill>
+                  <a:srgbClr val="A51C30"/>
+                </a:solidFill>
+                <a:latin typeface="Georgia"/>
+              </a:rPr>
+              <a:t>14 / 15</a:t>
+            </a:r>
+          </a:p>
+        </p:txBody>
+      </p:sp>
+      <p:sp>
+        <p:nvSpPr>
+          <p:cNvPr id="20" name="TextBox 19"/>
+          <p:cNvSpPr txBox="1"/>
+          <p:nvPr/>
+        </p:nvSpPr>
+        <p:spPr>
+          <a:xfrm>
+            <a:off x="33802320" y="8046720"/>
+            <a:ext cx="15666720" cy="1097280"/>
+          </a:xfrm>
+          <a:prstGeom prst="rect">
+            <a:avLst/>
+          </a:prstGeom>
+          <a:noFill/>
+        </p:spPr>
+        <p:txBody>
+          <a:bodyPr wrap="square" anchor="t">
+            <a:spAutoFit/>
+          </a:bodyPr>
+          <a:lstStyle/>
+          <a:p>
+            <a:pPr algn="ctr">
+              <a:lnSpc>
+                <a:spcPct val="120000"/>
+              </a:lnSpc>
+            </a:pPr>
+            <a:r>
+              <a:rPr sz="2200" b="0" i="1">
+                <a:solidFill>
+                  <a:srgbClr val="2A2A2A"/>
+                </a:solidFill>
+                <a:latin typeface="Calibri"/>
+              </a:rPr>
+              <a:t>known frauds recovered at the p85 suspicion cutoff.</a:t>
+            </a:r>
+          </a:p>
+          <a:p>
+            <a:pPr algn="ctr">
+              <a:lnSpc>
+                <a:spcPct val="120000"/>
+              </a:lnSpc>
+            </a:pPr>
+            <a:r>
+              <a:rPr sz="2200" b="0" i="1">
+                <a:solidFill>
+                  <a:srgbClr val="2A2A2A"/>
+                </a:solidFill>
+                <a:latin typeface="Calibri"/>
+              </a:rPr>
+              <a:t>The legacy three-vote consensus recovered 4 of 15.</a:t>
+            </a:r>
+          </a:p>
+        </p:txBody>
+      </p:sp>
+      <p:pic>
+        <p:nvPicPr>
+          <p:cNvPr id="21" name="Picture 20" descr="baseline_comparison.png"/>
+          <p:cNvPicPr>
+            <a:picLocks noChangeAspect="1"/>
+          </p:cNvPicPr>
+          <p:nvPr/>
+        </p:nvPicPr>
+        <p:blipFill>
+          <a:blip r:embed="rId4"/>
+          <a:stretch>
+            <a:fillRect/>
+          </a:stretch>
+        </p:blipFill>
+        <p:spPr>
+          <a:xfrm>
+            <a:off x="33802320" y="9601200"/>
+            <a:ext cx="15666720" cy="5303520"/>
+          </a:xfrm>
+          <a:prstGeom prst="rect">
+            <a:avLst/>
+          </a:prstGeom>
+        </p:spPr>
+      </p:pic>
+      <p:sp>
+        <p:nvSpPr>
+          <p:cNvPr id="22" name="TextBox 21"/>
+          <p:cNvSpPr txBox="1"/>
+          <p:nvPr/>
+        </p:nvSpPr>
+        <p:spPr>
+          <a:xfrm>
+            <a:off x="33802320" y="14950440"/>
+            <a:ext cx="15666720" cy="914400"/>
+          </a:xfrm>
+          <a:prstGeom prst="rect">
+            <a:avLst/>
+          </a:prstGeom>
+          <a:noFill/>
+        </p:spPr>
+        <p:txBody>
+          <a:bodyPr wrap="square" anchor="t">
+            <a:spAutoFit/>
+          </a:bodyPr>
+          <a:lstStyle/>
+          <a:p>
+            <a:pPr algn="ctr">
+              <a:lnSpc>
+                <a:spcPct val="120000"/>
+              </a:lnSpc>
+            </a:pPr>
+            <a:r>
+              <a:rPr sz="2200" b="0" i="1">
+                <a:solidFill>
+                  <a:srgbClr val="2A2A2A"/>
+                </a:solidFill>
+                <a:latin typeface="Calibri"/>
+              </a:rPr>
+              <a:t>Fig. 1.  Fraud recall on the n = 144 validated subset</a:t>
+            </a:r>
+          </a:p>
+          <a:p>
+            <a:pPr algn="ctr">
+              <a:lnSpc>
+                <a:spcPct val="120000"/>
+              </a:lnSpc>
+            </a:pPr>
+            <a:r>
+              <a:rPr sz="2200" b="0" i="1">
+                <a:solidFill>
+                  <a:srgbClr val="2A2A2A"/>
+                </a:solidFill>
+                <a:latin typeface="Calibri"/>
+              </a:rPr>
+              <a:t>(15 FRAUD, 129 non-fraud). Continuous suspicion</a:t>
+            </a:r>
+          </a:p>
+          <a:p>
+            <a:pPr algn="ctr">
+              <a:lnSpc>
+                <a:spcPct val="120000"/>
+              </a:lnSpc>
+            </a:pPr>
+            <a:r>
+              <a:rPr sz="2200" b="0" i="1">
+                <a:solidFill>
+                  <a:srgbClr val="2A2A2A"/>
+                </a:solidFill>
+                <a:latin typeface="Calibri"/>
+              </a:rPr>
+              <a:t>score catches 14 of 15 at p85; discrete voting catches 4.</a:t>
+            </a:r>
+          </a:p>
+        </p:txBody>
+      </p:sp>
+      <p:pic>
+        <p:nvPicPr>
+          <p:cNvPr id="23" name="Picture 22" descr="shap_global_importance.png"/>
+          <p:cNvPicPr>
+            <a:picLocks noChangeAspect="1"/>
+          </p:cNvPicPr>
+          <p:nvPr/>
+        </p:nvPicPr>
+        <p:blipFill>
+          <a:blip r:embed="rId5"/>
+          <a:stretch>
+            <a:fillRect/>
+          </a:stretch>
+        </p:blipFill>
+        <p:spPr>
+          <a:xfrm>
+            <a:off x="33802320" y="16733520"/>
+            <a:ext cx="15666720" cy="4389120"/>
+          </a:xfrm>
+          <a:prstGeom prst="rect">
+            <a:avLst/>
+          </a:prstGeom>
+        </p:spPr>
+      </p:pic>
+      <p:sp>
+        <p:nvSpPr>
+          <p:cNvPr id="24" name="TextBox 23"/>
+          <p:cNvSpPr txBox="1"/>
+          <p:nvPr/>
+        </p:nvSpPr>
+        <p:spPr>
+          <a:xfrm>
+            <a:off x="33802320" y="21168360"/>
+            <a:ext cx="15666720" cy="914400"/>
+          </a:xfrm>
+          <a:prstGeom prst="rect">
+            <a:avLst/>
+          </a:prstGeom>
+          <a:noFill/>
+        </p:spPr>
+        <p:txBody>
+          <a:bodyPr wrap="square" anchor="t">
+            <a:spAutoFit/>
+          </a:bodyPr>
+          <a:lstStyle/>
+          <a:p>
+            <a:pPr algn="ctr">
+              <a:lnSpc>
+                <a:spcPct val="120000"/>
+              </a:lnSpc>
+            </a:pPr>
+            <a:r>
+              <a:rPr sz="2200" b="0" i="1">
+                <a:solidFill>
+                  <a:srgbClr val="2A2A2A"/>
+                </a:solidFill>
+                <a:latin typeface="Calibri"/>
+              </a:rPr>
+              <a:t>Fig. 2.  SHAP attribution on Isolation Forest.</a:t>
+            </a:r>
+          </a:p>
+          <a:p>
+            <a:pPr algn="ctr">
+              <a:lnSpc>
+                <a:spcPct val="120000"/>
+              </a:lnSpc>
+            </a:pPr>
+            <a:r>
+              <a:rPr sz="2200" b="0" i="1">
+                <a:solidFill>
+                  <a:srgbClr val="2A2A2A"/>
+                </a:solidFill>
+                <a:latin typeface="Calibri"/>
+              </a:rPr>
+              <a:t>24-hour early velocity outranks the legacy volume-spike feature.</a:t>
+            </a:r>
+          </a:p>
+        </p:txBody>
+      </p:sp>
+      <p:sp>
+        <p:nvSpPr>
+          <p:cNvPr id="25" name="Rounded Rectangle 24"/>
+          <p:cNvSpPr/>
+          <p:nvPr/>
+        </p:nvSpPr>
+        <p:spPr>
+          <a:xfrm>
+            <a:off x="822960" y="32918400"/>
+            <a:ext cx="48646080" cy="4389120"/>
+          </a:xfrm>
+          <a:prstGeom prst="roundRect">
+            <a:avLst>
+              <a:gd name="adj" fmla="val 3000"/>
+            </a:avLst>
+          </a:prstGeom>
+          <a:solidFill>
+            <a:srgbClr val="A51C30"/>
+          </a:solidFill>
+          <a:ln>
+            <a:noFill/>
+          </a:ln>
+          <a:effectLst/>
+        </p:spPr>
+        <p:style>
+          <a:lnRef idx="1">
+            <a:schemeClr val="accent1"/>
+          </a:lnRef>
+          <a:fillRef idx="3">
+            <a:schemeClr val="accent1"/>
+          </a:fillRef>
+          <a:effectRef idx="2">
+            <a:schemeClr val="accent1"/>
+          </a:effectRef>
+          <a:fontRef idx="minor">
+            <a:schemeClr val="lt1"/>
+          </a:fontRef>
+        </p:style>
+        <p:txBody>
+          <a:bodyPr rtlCol="0" anchor="ctr"/>
+          <a:lstStyle/>
+          <a:p>
+            <a:pPr algn="ctr"/>
+          </a:p>
+        </p:txBody>
+      </p:sp>
       <p:sp>
         <p:nvSpPr>
           <p:cNvPr id="26" name="TextBox 25"/>
@@ -4592,98 +4571,203 @@
           <p:nvPr/>
         </p:nvSpPr>
         <p:spPr>
-          <xfrm>
-            <off x="36875258" y="23791025"/>
-            <ext cx="17090967" cy="798021"/>
-          </xfrm>
-          <prstGeom prst="rect">
-            <avLst/>
-          </prstGeom>
-          <noFill/>
+          <a:xfrm>
+            <a:off x="1371600" y="33147000"/>
+            <a:ext cx="47548800" cy="1005840"/>
+          </a:xfrm>
+          <a:prstGeom prst="rect">
+            <a:avLst/>
+          </a:prstGeom>
+          <a:noFill/>
         </p:spPr>
         <p:txBody>
-          <bodyPr wrap="square" anchor="t">
-            <spAutoFit/>
-          </bodyPr>
-          <lstStyle/>
-          <p>
-            <pPr algn="ctr">
-              <lnSpc>
-                <spcPct val="115000"/>
-              </lnSpc>
-            </pPr>
-            <r>
-              <rPr sz="2400" b="0" i="1">
-                <solidFill>
-                  <srgbClr val="2A2A2A"/>
-                </solidFill>
-                <latin typeface="Calibri"/>
-              </rPr>
-              <t>Fig. 2.  SHAP attribution on Isolation Forest.  Early 24-hour</t>
-            </r>
-          </p>
-          <p>
-            <pPr algn="ctr">
-              <lnSpc>
-                <spcPct val="115000"/>
-              </lnSpc>
-            </pPr>
-            <r>
-              <rPr sz="2400" b="0" i="1">
-                <solidFill>
-                  <srgbClr val="2A2A2A"/>
-                </solidFill>
-                <latin typeface="Calibri"/>
-              </rPr>
-              <t>velocity outranks the legacy headline feature (volume spike ratio).</t>
-            </r>
-          </p>
-        </p:txBody>
-      </p:sp>
-      <p:sp>
-        <p:nvSpPr>
-          <p:cNvPr id="27" name="Rounded Rectangle 26"/>
-          <p:cNvSpPr/>
+          <a:bodyPr wrap="square" anchor="t">
+            <a:spAutoFit/>
+          </a:bodyPr>
+          <a:lstStyle/>
+          <a:p>
+            <a:pPr algn="l">
+              <a:lnSpc>
+                <a:spcPct val="120000"/>
+              </a:lnSpc>
+            </a:pPr>
+            <a:r>
+              <a:rPr sz="3200" b="1" i="0">
+                <a:solidFill>
+                  <a:srgbClr val="FFFFFF"/>
+                </a:solidFill>
+                <a:latin typeface="Calibri"/>
+              </a:rPr>
+              <a:t>SO WHAT</a:t>
+            </a:r>
+          </a:p>
+        </p:txBody>
+      </p:sp>
+      <p:sp>
+        <p:nvSpPr>
+          <p:cNvPr id="27" name="TextBox 26"/>
+          <p:cNvSpPr txBox="1"/>
           <p:nvPr/>
         </p:nvSpPr>
         <p:spPr>
-          <xfrm>
-            <off x="897774" y="35412218"/>
-            <ext cx="53068450" cy="5187141"/>
-          </xfrm>
-          <prstGeom prst="roundRect">
-            <avLst>
-              <gd name="adj" fmla="val 3000"/>
-            </avLst>
-          </prstGeom>
-          <solidFill>
-            <srgbClr val="A51C30"/>
-          </solidFill>
-          <ln>
-            <noFill/>
-          </ln>
-          <effectLst/>
+          <a:xfrm>
+            <a:off x="1371600" y="34152840"/>
+            <a:ext cx="47548800" cy="3108960"/>
+          </a:xfrm>
+          <a:prstGeom prst="rect">
+            <a:avLst/>
+          </a:prstGeom>
+          <a:noFill/>
         </p:spPr>
-        <p:style>
-          <lnRef idx="1">
-            <schemeClr val="accent1"/>
-          </lnRef>
-          <fillRef idx="3">
-            <schemeClr val="accent1"/>
-          </fillRef>
-          <effectRef idx="2">
-            <schemeClr val="accent1"/>
-          </effectRef>
-          <fontRef idx="minor">
-            <schemeClr val="lt1"/>
-          </fontRef>
-        </p:style>
-        <p:txBody>
-          <bodyPr rtlCol="0" anchor="ctr"/>
-          <lstStyle/>
-          <p>
-            <pPr algn="ctr"/>
-          </p>
+        <p:txBody>
+          <a:bodyPr wrap="square" anchor="t">
+            <a:spAutoFit/>
+          </a:bodyPr>
+          <a:lstStyle/>
+          <a:p>
+            <a:pPr algn="l">
+              <a:lnSpc>
+                <a:spcPct val="125000"/>
+              </a:lnSpc>
+            </a:pPr>
+            <a:r>
+              <a:rPr sz="2400" b="0" i="0">
+                <a:solidFill>
+                  <a:srgbClr val="FFFFFF"/>
+                </a:solidFill>
+                <a:latin typeface="Calibri"/>
+              </a:rPr>
+              <a:t>Continuous ranking beats discrete voting.  A rank-averaged suspicion score recovered 14 of 15 known</a:t>
+            </a:r>
+          </a:p>
+          <a:p>
+            <a:pPr algn="l">
+              <a:lnSpc>
+                <a:spcPct val="125000"/>
+              </a:lnSpc>
+            </a:pPr>
+            <a:r>
+              <a:rPr sz="2400" b="0" i="0">
+                <a:solidFill>
+                  <a:srgbClr val="FFFFFF"/>
+                </a:solidFill>
+                <a:latin typeface="Calibri"/>
+              </a:rPr>
+              <a:t>frauds on the validated subset; the legacy "3 of 3 detectors agree" rule recovered only 4 of 15.</a:t>
+            </a:r>
+          </a:p>
+          <a:p>
+            <a:pPr algn="l">
+              <a:lnSpc>
+                <a:spcPct val="125000"/>
+              </a:lnSpc>
+            </a:pPr>
+            <a:r>
+              <a:rPr sz="2400" b="0" i="0">
+                <a:solidFill>
+                  <a:srgbClr val="FFFFFF"/>
+                </a:solidFill>
+                <a:latin typeface="Calibri"/>
+              </a:rPr>
+              <a:t/>
+            </a:r>
+          </a:p>
+          <a:p>
+            <a:pPr algn="l">
+              <a:lnSpc>
+                <a:spcPct val="125000"/>
+              </a:lnSpc>
+            </a:pPr>
+            <a:r>
+              <a:rPr sz="2400" b="0" i="0">
+                <a:solidFill>
+                  <a:srgbClr val="FFFFFF"/>
+                </a:solidFill>
+                <a:latin typeface="Calibri"/>
+              </a:rPr>
+              <a:t>Two layers separate 'anomaly' from 'fraud.'  The Layer-2 calibrator achieves 88% specificity —</a:t>
+            </a:r>
+          </a:p>
+          <a:p>
+            <a:pPr algn="l">
+              <a:lnSpc>
+                <a:spcPct val="125000"/>
+              </a:lnSpc>
+            </a:pPr>
+            <a:r>
+              <a:rPr sz="2400" b="0" i="0">
+                <a:solidFill>
+                  <a:srgbClr val="FFFFFF"/>
+                </a:solidFill>
+                <a:latin typeface="Calibri"/>
+              </a:rPr>
+              <a:t>blue-chip tokens (WLFI, DEGEN, MIM, 3Crv) that trigger Layer 1 alarms all score P(fraud) &lt; 0.06,</a:t>
+            </a:r>
+          </a:p>
+          <a:p>
+            <a:pPr algn="l">
+              <a:lnSpc>
+                <a:spcPct val="125000"/>
+              </a:lnSpc>
+            </a:pPr>
+            <a:r>
+              <a:rPr sz="2400" b="0" i="0">
+                <a:solidFill>
+                  <a:srgbClr val="FFFFFF"/>
+                </a:solidFill>
+                <a:latin typeface="Calibri"/>
+              </a:rPr>
+              <a:t>while known rugs (WFT, PLASMA, ORBDEG cluster) score P(fraud) &gt; 0.8. Leave-one-out accuracy 0.87.</a:t>
+            </a:r>
+          </a:p>
+          <a:p>
+            <a:pPr algn="l">
+              <a:lnSpc>
+                <a:spcPct val="125000"/>
+              </a:lnSpc>
+            </a:pPr>
+            <a:r>
+              <a:rPr sz="2400" b="0" i="0">
+                <a:solidFill>
+                  <a:srgbClr val="FFFFFF"/>
+                </a:solidFill>
+                <a:latin typeface="Calibri"/>
+              </a:rPr>
+              <a:t/>
+            </a:r>
+          </a:p>
+          <a:p>
+            <a:pPr algn="l">
+              <a:lnSpc>
+                <a:spcPct val="125000"/>
+              </a:lnSpc>
+            </a:pPr>
+            <a:r>
+              <a:rPr sz="2400" b="0" i="0">
+                <a:solidFill>
+                  <a:srgbClr val="FFFFFF"/>
+                </a:solidFill>
+                <a:latin typeface="Calibri"/>
+              </a:rPr>
+              <a:t>Remaining limitations.  Small-volume honeypots (HYPER, KUBO) still slip through — catching them</a:t>
+            </a:r>
+          </a:p>
+          <a:p>
+            <a:pPr algn="l">
+              <a:lnSpc>
+                <a:spcPct val="125000"/>
+              </a:lnSpc>
+            </a:pPr>
+            <a:r>
+              <a:rPr sz="2400" b="0" i="0">
+                <a:solidFill>
+                  <a:srgbClr val="FFFFFF"/>
+                </a:solidFill>
+                <a:latin typeface="Calibri"/>
+              </a:rPr>
+              <a:t>requires graph-level signals (deployer history, liquidity-pool removal) beyond on-chain volume.</a:t>
+            </a:r>
+          </a:p>
         </p:txBody>
       </p:sp>
       <p:sp>
@@ -4693,36 +4777,68 @@
           <p:nvPr/>
         </p:nvSpPr>
         <p:spPr>
-          <xfrm>
-            <off x="1496290" y="35711476"/>
-            <ext cx="51871418" cy="1097280"/>
-          </xfrm>
-          <prstGeom prst="rect">
-            <avLst/>
-          </prstGeom>
-          <noFill/>
+          <a:xfrm>
+            <a:off x="822960" y="37627560"/>
+            <a:ext cx="24323040" cy="2331720"/>
+          </a:xfrm>
+          <a:prstGeom prst="rect">
+            <a:avLst/>
+          </a:prstGeom>
+          <a:noFill/>
         </p:spPr>
         <p:txBody>
-          <bodyPr wrap="square" anchor="t">
-            <spAutoFit/>
-          </bodyPr>
-          <lstStyle/>
-          <p>
-            <pPr algn="l">
-              <lnSpc>
-                <spcPct val="115000"/>
-              </lnSpc>
-            </pPr>
-            <r>
-              <rPr sz="3490" b="1" i="0">
-                <solidFill>
-                  <srgbClr val="FFFFFF"/>
-                </solidFill>
-                <latin typeface="Calibri"/>
-              </rPr>
-              <t>SO WHAT</t>
-            </r>
-          </p>
+          <a:bodyPr wrap="square" anchor="t">
+            <a:spAutoFit/>
+          </a:bodyPr>
+          <a:lstStyle/>
+          <a:p>
+            <a:pPr algn="l">
+              <a:lnSpc>
+                <a:spcPct val="130000"/>
+              </a:lnSpc>
+            </a:pPr>
+            <a:r>
+              <a:rPr sz="2200" b="0" i="0">
+                <a:solidFill>
+                  <a:srgbClr val="2A2A2A"/>
+                </a:solidFill>
+                <a:latin typeface="Calibri"/>
+              </a:rPr>
+              <a:t>Code:      github.com/gschriever/AC297r-crypto-fraud-detector</a:t>
+            </a:r>
+          </a:p>
+          <a:p>
+            <a:pPr algn="l">
+              <a:lnSpc>
+                <a:spcPct val="130000"/>
+              </a:lnSpc>
+            </a:pPr>
+            <a:r>
+              <a:rPr sz="2200" b="0" i="0">
+                <a:solidFill>
+                  <a:srgbClr val="2A2A2A"/>
+                </a:solidFill>
+                <a:latin typeface="Calibri"/>
+              </a:rPr>
+              <a:t>Contact:   [ name ]  ·  [ email ]</a:t>
+            </a:r>
+          </a:p>
+          <a:p>
+            <a:pPr algn="l">
+              <a:lnSpc>
+                <a:spcPct val="130000"/>
+              </a:lnSpc>
+            </a:pPr>
+            <a:r>
+              <a:rPr sz="2200" b="0" i="0">
+                <a:solidFill>
+                  <a:srgbClr val="2A2A2A"/>
+                </a:solidFill>
+                <a:latin typeface="Calibri"/>
+              </a:rPr>
+              <a:t>Advisor:   [ advisor ]</a:t>
+            </a:r>
+          </a:p>
         </p:txBody>
       </p:sp>
       <p:sp>
@@ -4732,296 +4848,74 @@
           <p:nvPr/>
         </p:nvSpPr>
         <p:spPr>
-          <xfrm>
-            <off x="1496290" y="36808756"/>
-            <ext cx="51871418" cy="3690850"/>
-          </xfrm>
-          <prstGeom prst="rect">
-            <avLst/>
-          </prstGeom>
-          <noFill/>
+          <a:xfrm>
+            <a:off x="25146000" y="37627560"/>
+            <a:ext cx="24323040" cy="2331720"/>
+          </a:xfrm>
+          <a:prstGeom prst="rect">
+            <a:avLst/>
+          </a:prstGeom>
+          <a:noFill/>
         </p:spPr>
         <p:txBody>
-          <bodyPr wrap="square" anchor="t">
-            <spAutoFit/>
-          </bodyPr>
-          <lstStyle/>
-          <p>
-            <pPr algn="l">
-              <lnSpc>
-                <spcPct val="125000"/>
-              </lnSpc>
-            </pPr>
-            <r>
-              <rPr sz="2836" b="0" i="0">
-                <solidFill>
-                  <srgbClr val="FFFFFF"/>
-                </solidFill>
-                <latin typeface="Calibri"/>
-              </rPr>
-              <t>Continuous ranking beats discrete voting.  A rank-averaged suspicion score recovered 6/6 known</t>
-            </r>
-          </p>
-          <p>
-            <pPr algn="l">
-              <lnSpc>
-                <spcPct val="125000"/>
-              </lnSpc>
-            </pPr>
-            <r>
-              <rPr sz="2836" b="0" i="0">
-                <solidFill>
-                  <srgbClr val="FFFFFF"/>
-                </solidFill>
-                <latin typeface="Calibri"/>
-              </rPr>
-              <t>frauds on the validated subset; the legacy "3 of 3 detectors agree" rule recovered 1/6.</t>
-            </r>
-          </p>
-          <p>
-            <pPr algn="l">
-              <lnSpc>
-                <spcPct val="125000"/>
-              </lnSpc>
-            </pPr>
-            <r>
-              <rPr sz="2836" b="0" i="0">
-                <solidFill>
-                  <srgbClr val="FFFFFF"/>
-                </solidFill>
-                <latin typeface="Calibri"/>
-              </rPr>
-              <t/>
-            </r>
-          </p>
-          <p>
-            <pPr algn="l">
-              <lnSpc>
-                <spcPct val="125000"/>
-              </lnSpc>
-            </pPr>
-            <r>
-              <rPr sz="2836" b="0" i="0">
-                <solidFill>
-                  <srgbClr val="FFFFFF"/>
-                </solidFill>
-                <latin typeface="Calibri"/>
-              </rPr>
-              <t>Two layers separate 'anomaly' from 'fraud.'  The Layer-2 calibrator cleanly distinguishes rug-pulls</t>
-            </r>
-          </p>
-          <p>
-            <pPr algn="l">
-              <lnSpc>
-                <spcPct val="125000"/>
-              </lnSpc>
-            </pPr>
-            <r>
-              <rPr sz="2836" b="0" i="0">
-                <solidFill>
-                  <srgbClr val="FFFFFF"/>
-                </solidFill>
-                <latin typeface="Calibri"/>
-              </rPr>
-              <t>(P ≈ 0.5–0.7) from large legitimate events like hacks and de-peg shocks (P ≈ 0.1–0.2).</t>
-            </r>
-          </p>
-          <p>
-            <pPr algn="l">
-              <lnSpc>
-                <spcPct val="125000"/>
-              </lnSpc>
-            </pPr>
-            <r>
-              <rPr sz="2836" b="0" i="0">
-                <solidFill>
-                  <srgbClr val="FFFFFF"/>
-                </solidFill>
-                <latin typeface="Calibri"/>
-              </rPr>
-              <t/>
-            </r>
-          </p>
-          <p>
-            <pPr algn="l">
-              <lnSpc>
-                <spcPct val="125000"/>
-              </lnSpc>
-            </pPr>
-            <r>
-              <rPr sz="2836" b="0" i="0">
-                <solidFill>
-                  <srgbClr val="FFFFFF"/>
-                </solidFill>
-                <latin typeface="Calibri"/>
-              </rPr>
-              <t>Key caveat.  The calibration layer is trained on only 14 hand-validated tokens; expanding that</t>
-            </r>
-          </p>
-          <p>
-            <pPr algn="l">
-              <lnSpc>
-                <spcPct val="125000"/>
-              </lnSpc>
-            </pPr>
-            <r>
-              <rPr sz="2836" b="0" i="0">
-                <solidFill>
-                  <srgbClr val="FFFFFF"/>
-                </solidFill>
-                <latin typeface="Calibri"/>
-              </rPr>
-              <t>labeled set is the single most valuable next step.</t>
-            </r>
-          </p>
-        </p:txBody>
-      </p:sp>
-      <p:sp>
-        <p:nvSpPr>
-          <p:cNvPr id="30" name="TextBox 29"/>
-          <p:cNvSpPr txBox="1"/>
-          <p:nvPr/>
-        </p:nvSpPr>
-        <p:spPr>
-          <xfrm>
-            <off x="897774" y="40998370"/>
-            <ext cx="26534225" cy="2493818"/>
-          </xfrm>
-          <prstGeom prst="rect">
-            <avLst/>
-          </prstGeom>
-          <noFill/>
-        </p:spPr>
-        <p:txBody>
-          <bodyPr wrap="square" anchor="t">
-            <spAutoFit/>
-          </bodyPr>
-          <lstStyle/>
-          <p>
-            <pPr algn="l">
-              <lnSpc>
-                <spcPct val="130000"/>
-              </lnSpc>
-            </pPr>
-            <r>
-              <rPr sz="2400" b="0" i="0">
-                <solidFill>
-                  <srgbClr val="2A2A2A"/>
-                </solidFill>
-                <latin typeface="Calibri"/>
-              </rPr>
-              <t>Code:      github.com/gschriever/AC297r-crypto-fraud-detector</t>
-            </r>
-          </p>
-          <p>
-            <pPr algn="l">
-              <lnSpc>
-                <spcPct val="130000"/>
-              </lnSpc>
-            </pPr>
-            <r>
-              <rPr sz="2400" b="0" i="0">
-                <solidFill>
-                  <srgbClr val="2A2A2A"/>
-                </solidFill>
-                <latin typeface="Calibri"/>
-              </rPr>
-              <t>Contact:   [ name ]  ·  [ email ]</t>
-            </r>
-          </p>
-          <p>
-            <pPr algn="l">
-              <lnSpc>
-                <spcPct val="130000"/>
-              </lnSpc>
-            </pPr>
-            <r>
-              <rPr sz="2400" b="0" i="0">
-                <solidFill>
-                  <srgbClr val="2A2A2A"/>
-                </solidFill>
-                <latin typeface="Calibri"/>
-              </rPr>
-              <t>Advisor:   [ advisor ]</t>
-            </r>
-          </p>
-        </p:txBody>
-      </p:sp>
-      <p:sp>
-        <p:nvSpPr>
-          <p:cNvPr id="31" name="TextBox 30"/>
-          <p:cNvSpPr txBox="1"/>
-          <p:nvPr/>
-        </p:nvSpPr>
-        <p:spPr>
-          <xfrm>
-            <off x="27431999" y="40998370"/>
-            <ext cx="26534225" cy="2493818"/>
-          </xfrm>
-          <prstGeom prst="rect">
-            <avLst/>
-          </prstGeom>
-          <noFill/>
-        </p:spPr>
-        <p:txBody>
-          <bodyPr wrap="square" anchor="t">
-            <spAutoFit/>
-          </bodyPr>
-          <lstStyle/>
-          <p>
-            <pPr algn="l">
-              <lnSpc>
-                <spcPct val="130000"/>
-              </lnSpc>
-            </pPr>
-            <r>
-              <rPr sz="2400" b="0" i="0">
-                <solidFill>
-                  <srgbClr val="2A2A2A"/>
-                </solidFill>
-                <latin typeface="Calibri"/>
-              </rPr>
-              <t>[1] Mazorra et al.  Do Not Rug on Me.  arXiv:2201.07220, 2022.</t>
-            </r>
-          </p>
-          <p>
-            <pPr algn="l">
-              <lnSpc>
-                <spcPct val="130000"/>
-              </lnSpc>
-            </pPr>
-            <r>
-              <rPr sz="2400" b="0" i="0">
-                <solidFill>
-                  <srgbClr val="2A2A2A"/>
-                </solidFill>
-                <latin typeface="Calibri"/>
-              </rPr>
-              <t>[2] Liu, Ting &amp; Zhou.  Isolation Forest.  ICDM 2008.</t>
-            </r>
-          </p>
-          <p>
-            <pPr algn="l">
-              <lnSpc>
-                <spcPct val="130000"/>
-              </lnSpc>
-            </pPr>
-            <r>
-              <rPr sz="2400" b="0" i="0">
-                <solidFill>
-                  <srgbClr val="2A2A2A"/>
-                </solidFill>
-                <latin typeface="Calibri"/>
-              </rPr>
-              <t>[3] Lundberg &amp; Lee.  SHAP.  NeurIPS 2017.</t>
-            </r>
-          </p>
+          <a:bodyPr wrap="square" anchor="t">
+            <a:spAutoFit/>
+          </a:bodyPr>
+          <a:lstStyle/>
+          <a:p>
+            <a:pPr algn="l">
+              <a:lnSpc>
+                <a:spcPct val="130000"/>
+              </a:lnSpc>
+            </a:pPr>
+            <a:r>
+              <a:rPr sz="2200" b="0" i="0">
+                <a:solidFill>
+                  <a:srgbClr val="2A2A2A"/>
+                </a:solidFill>
+                <a:latin typeface="Calibri"/>
+              </a:rPr>
+              <a:t>[1] Mazorra et al.  Do Not Rug on Me.  arXiv:2201.07220, 2022.</a:t>
+            </a:r>
+          </a:p>
+          <a:p>
+            <a:pPr algn="l">
+              <a:lnSpc>
+                <a:spcPct val="130000"/>
+              </a:lnSpc>
+            </a:pPr>
+            <a:r>
+              <a:rPr sz="2200" b="0" i="0">
+                <a:solidFill>
+                  <a:srgbClr val="2A2A2A"/>
+                </a:solidFill>
+                <a:latin typeface="Calibri"/>
+              </a:rPr>
+              <a:t>[2] Liu, Ting &amp; Zhou.  Isolation Forest.  ICDM 2008.</a:t>
+            </a:r>
+          </a:p>
+          <a:p>
+            <a:pPr algn="l">
+              <a:lnSpc>
+                <a:spcPct val="130000"/>
+              </a:lnSpc>
+            </a:pPr>
+            <a:r>
+              <a:rPr sz="2200" b="0" i="0">
+                <a:solidFill>
+                  <a:srgbClr val="2A2A2A"/>
+                </a:solidFill>
+                <a:latin typeface="Calibri"/>
+              </a:rPr>
+              <a:t>[3] Lundberg &amp; Lee.  SHAP.  NeurIPS 2017.</a:t>
+            </a:r>
+          </a:p>
         </p:txBody>
       </p:sp>
     </p:spTree>
   </p:cSld>
   <p:clrMapOvr>
-    <masterClrMapping/>
+    <a:masterClrMapping/>
   </p:clrMapOvr>
 </p:sld>
 </file>

</xml_diff>